<commit_message>
Remove demo flow slide from PPT (now 13 slides)
</commit_message>
<xml_diff>
--- a/SC_Risk_Intelligence_PPT.pptx
+++ b/SC_Risk_Intelligence_PPT.pptx
@@ -18,7 +18,6 @@
     <p:sldId id="266" r:id="rId17"/>
     <p:sldId id="267" r:id="rId18"/>
     <p:sldId id="268" r:id="rId19"/>
-    <p:sldId id="269" r:id="rId20"/>
   </p:sldIdLst>
   <p:sldSz cx="12188952" cy="6858000" type="screen4x3"/>
   <p:notesSz cx="6858000" cy="9144000"/>
@@ -6886,7 +6885,7 @@
                   <a:srgbClr val="FFFFFF"/>
                 </a:solidFill>
               </a:rPr>
-              <a:t>Demo Flow  —  10 Minutes</a:t>
+              <a:t>Performance &amp; Results</a:t>
             </a:r>
           </a:p>
         </p:txBody>
@@ -6920,7 +6919,7 @@
                   <a:srgbClr val="C8D3E8"/>
                 </a:solidFill>
               </a:rPr>
-              <a:t>Operations manager investigates a supply chain disruption end-to-end</a:t>
+              <a:t>Live test results on 600-incident corpus with local sentence-transformer embeddings</a:t>
             </a:r>
           </a:p>
         </p:txBody>
@@ -6976,8 +6975,8 @@
         </p:nvSpPr>
         <p:spPr>
           <a:xfrm>
-            <a:off x="320040" y="1444752"/>
-            <a:ext cx="1536192" cy="530352"/>
+            <a:off x="365760" y="1444752"/>
+            <a:ext cx="3657600" cy="54864"/>
           </a:xfrm>
           <a:prstGeom prst="rect">
             <a:avLst/>
@@ -7013,58 +7012,25 @@
       </p:sp>
       <p:sp>
         <p:nvSpPr>
-          <p:cNvPr id="8" name="TextBox 7"/>
-          <p:cNvSpPr txBox="1"/>
-          <p:nvPr/>
-        </p:nvSpPr>
-        <p:spPr>
-          <a:xfrm>
-            <a:off x="320040" y="1444752"/>
-            <a:ext cx="1536192" cy="530352"/>
-          </a:xfrm>
-          <a:prstGeom prst="rect">
-            <a:avLst/>
-          </a:prstGeom>
-          <a:noFill/>
-        </p:spPr>
-        <p:txBody>
-          <a:bodyPr wrap="square">
-            <a:spAutoFit/>
-          </a:bodyPr>
-          <a:lstStyle/>
-          <a:p>
-            <a:pPr algn="ctr"/>
-            <a:r>
-              <a:rPr sz="900" b="1" i="0">
-                <a:solidFill>
-                  <a:srgbClr val="FFFFFF"/>
-                </a:solidFill>
-              </a:rPr>
-              <a:t>00:00
-–01:00</a:t>
-            </a:r>
-          </a:p>
-        </p:txBody>
-      </p:sp>
-      <p:sp>
-        <p:nvSpPr>
-          <p:cNvPr id="9" name="Rectangle 8"/>
+          <p:cNvPr id="8" name="Rectangle 7"/>
           <p:cNvSpPr/>
           <p:nvPr/>
         </p:nvSpPr>
         <p:spPr>
           <a:xfrm>
-            <a:off x="320040" y="1975104"/>
-            <a:ext cx="1536192" cy="502920"/>
-          </a:xfrm>
-          <a:prstGeom prst="rect">
-            <a:avLst/>
-          </a:prstGeom>
-          <a:solidFill>
-            <a:srgbClr val="F05A28"/>
-          </a:solidFill>
-          <a:ln>
-            <a:noFill/>
+            <a:off x="365760" y="1499616"/>
+            <a:ext cx="3657600" cy="2057400"/>
+          </a:xfrm>
+          <a:prstGeom prst="rect">
+            <a:avLst/>
+          </a:prstGeom>
+          <a:solidFill>
+            <a:srgbClr val="EEF2F8"/>
+          </a:solidFill>
+          <a:ln w="10160">
+            <a:solidFill>
+              <a:srgbClr val="1C3461"/>
+            </a:solidFill>
           </a:ln>
         </p:spPr>
         <p:style>
@@ -7091,60 +7057,125 @@
       </p:sp>
       <p:sp>
         <p:nvSpPr>
+          <p:cNvPr id="9" name="TextBox 8"/>
+          <p:cNvSpPr txBox="1"/>
+          <p:nvPr/>
+        </p:nvSpPr>
+        <p:spPr>
+          <a:xfrm>
+            <a:off x="365760" y="1609344"/>
+            <a:ext cx="3657600" cy="822960"/>
+          </a:xfrm>
+          <a:prstGeom prst="rect">
+            <a:avLst/>
+          </a:prstGeom>
+          <a:noFill/>
+        </p:spPr>
+        <p:txBody>
+          <a:bodyPr wrap="square">
+            <a:spAutoFit/>
+          </a:bodyPr>
+          <a:lstStyle/>
+          <a:p>
+            <a:pPr algn="ctr"/>
+            <a:r>
+              <a:rPr sz="3200" b="1" i="0">
+                <a:solidFill>
+                  <a:srgbClr val="1C3461"/>
+                </a:solidFill>
+              </a:rPr>
+              <a:t>40 ms</a:t>
+            </a:r>
+          </a:p>
+        </p:txBody>
+      </p:sp>
+      <p:sp>
+        <p:nvSpPr>
           <p:cNvPr id="10" name="TextBox 9"/>
           <p:cNvSpPr txBox="1"/>
           <p:nvPr/>
         </p:nvSpPr>
         <p:spPr>
           <a:xfrm>
-            <a:off x="320040" y="1975104"/>
-            <a:ext cx="1536192" cy="502920"/>
-          </a:xfrm>
-          <a:prstGeom prst="rect">
-            <a:avLst/>
-          </a:prstGeom>
-          <a:noFill/>
-        </p:spPr>
-        <p:txBody>
-          <a:bodyPr wrap="square">
-            <a:spAutoFit/>
-          </a:bodyPr>
-          <a:lstStyle/>
-          <a:p>
-            <a:pPr algn="ctr"/>
-            <a:r>
-              <a:rPr sz="1000" b="1" i="0">
-                <a:solidFill>
-                  <a:srgbClr val="FFFFFF"/>
-                </a:solidFill>
-              </a:rPr>
-              <a:t>Problem
-Statement</a:t>
-            </a:r>
-          </a:p>
-        </p:txBody>
-      </p:sp>
-      <p:sp>
-        <p:nvSpPr>
-          <p:cNvPr id="11" name="Rectangle 10"/>
+            <a:off x="365760" y="2450592"/>
+            <a:ext cx="3657600" cy="365760"/>
+          </a:xfrm>
+          <a:prstGeom prst="rect">
+            <a:avLst/>
+          </a:prstGeom>
+          <a:noFill/>
+        </p:spPr>
+        <p:txBody>
+          <a:bodyPr wrap="square">
+            <a:spAutoFit/>
+          </a:bodyPr>
+          <a:lstStyle/>
+          <a:p>
+            <a:pPr algn="ctr"/>
+            <a:r>
+              <a:rPr sz="1300" b="1" i="0">
+                <a:solidFill>
+                  <a:srgbClr val="1C3461"/>
+                </a:solidFill>
+              </a:rPr>
+              <a:t>Search Latency</a:t>
+            </a:r>
+          </a:p>
+        </p:txBody>
+      </p:sp>
+      <p:sp>
+        <p:nvSpPr>
+          <p:cNvPr id="11" name="TextBox 10"/>
+          <p:cNvSpPr txBox="1"/>
+          <p:nvPr/>
+        </p:nvSpPr>
+        <p:spPr>
+          <a:xfrm>
+            <a:off x="457200" y="2862072"/>
+            <a:ext cx="3474720" cy="640080"/>
+          </a:xfrm>
+          <a:prstGeom prst="rect">
+            <a:avLst/>
+          </a:prstGeom>
+          <a:noFill/>
+        </p:spPr>
+        <p:txBody>
+          <a:bodyPr wrap="square">
+            <a:spAutoFit/>
+          </a:bodyPr>
+          <a:lstStyle/>
+          <a:p>
+            <a:pPr algn="ctr"/>
+            <a:r>
+              <a:rPr sz="1000" b="0" i="0">
+                <a:solidFill>
+                  <a:srgbClr val="6B7A9A"/>
+                </a:solidFill>
+              </a:rPr>
+              <a:t>Hybrid BM25+Semantic (local embeddings)</a:t>
+            </a:r>
+          </a:p>
+        </p:txBody>
+      </p:sp>
+      <p:sp>
+        <p:nvSpPr>
+          <p:cNvPr id="12" name="Rectangle 11"/>
           <p:cNvSpPr/>
           <p:nvPr/>
         </p:nvSpPr>
         <p:spPr>
           <a:xfrm>
-            <a:off x="320040" y="2478024"/>
-            <a:ext cx="1536192" cy="4069080"/>
-          </a:xfrm>
-          <a:prstGeom prst="rect">
-            <a:avLst/>
-          </a:prstGeom>
-          <a:solidFill>
-            <a:srgbClr val="EEF2F8"/>
-          </a:solidFill>
-          <a:ln w="12700">
-            <a:solidFill>
-              <a:srgbClr val="1C3461"/>
-            </a:solidFill>
+            <a:off x="4297680" y="1444752"/>
+            <a:ext cx="3657600" cy="54864"/>
+          </a:xfrm>
+          <a:prstGeom prst="rect">
+            <a:avLst/>
+          </a:prstGeom>
+          <a:solidFill>
+            <a:srgbClr val="243D72"/>
+          </a:solidFill>
+          <a:ln>
+            <a:noFill/>
           </a:ln>
         </p:spPr>
         <p:style>
@@ -7171,92 +7202,25 @@
       </p:sp>
       <p:sp>
         <p:nvSpPr>
-          <p:cNvPr id="12" name="TextBox 11"/>
-          <p:cNvSpPr txBox="1"/>
-          <p:nvPr/>
-        </p:nvSpPr>
-        <p:spPr>
-          <a:xfrm>
-            <a:off x="393192" y="2578608"/>
-            <a:ext cx="1389888" cy="3840480"/>
-          </a:xfrm>
-          <a:prstGeom prst="rect">
-            <a:avLst/>
-          </a:prstGeom>
-          <a:noFill/>
-        </p:spPr>
-        <p:txBody>
-          <a:bodyPr wrap="square">
-            <a:spAutoFit/>
-          </a:bodyPr>
-          <a:lstStyle/>
-          <a:p>
-            <a:pPr algn="l"/>
-            <a:r>
-              <a:rPr sz="950" b="0" i="0">
-                <a:solidFill>
-                  <a:srgbClr val="1A2038"/>
-                </a:solidFill>
-              </a:rPr>
-              <a:t>Explain the supply chain intelligence gap.
-Distributed data · Reactive monitoring · Manual analysis.</a:t>
-            </a:r>
-          </a:p>
-        </p:txBody>
-      </p:sp>
-      <p:sp>
-        <p:nvSpPr>
-          <p:cNvPr id="13" name="TextBox 12"/>
-          <p:cNvSpPr txBox="1"/>
-          <p:nvPr/>
-        </p:nvSpPr>
-        <p:spPr>
-          <a:xfrm>
-            <a:off x="1901952" y="2606040"/>
-            <a:ext cx="146304" cy="365760"/>
-          </a:xfrm>
-          <a:prstGeom prst="rect">
-            <a:avLst/>
-          </a:prstGeom>
-          <a:noFill/>
-        </p:spPr>
-        <p:txBody>
-          <a:bodyPr wrap="square">
-            <a:spAutoFit/>
-          </a:bodyPr>
-          <a:lstStyle/>
-          <a:p>
-            <a:pPr algn="ctr"/>
-            <a:r>
-              <a:rPr sz="1300" b="1" i="0">
-                <a:solidFill>
-                  <a:srgbClr val="F05A28"/>
-                </a:solidFill>
-              </a:rPr>
-              <a:t>→</a:t>
-            </a:r>
-          </a:p>
-        </p:txBody>
-      </p:sp>
-      <p:sp>
-        <p:nvSpPr>
-          <p:cNvPr id="14" name="Rectangle 13"/>
+          <p:cNvPr id="13" name="Rectangle 12"/>
           <p:cNvSpPr/>
           <p:nvPr/>
         </p:nvSpPr>
         <p:spPr>
           <a:xfrm>
-            <a:off x="2002536" y="1444752"/>
-            <a:ext cx="1536192" cy="530352"/>
-          </a:xfrm>
-          <a:prstGeom prst="rect">
-            <a:avLst/>
-          </a:prstGeom>
-          <a:solidFill>
-            <a:srgbClr val="1C3461"/>
-          </a:solidFill>
-          <a:ln>
-            <a:noFill/>
+            <a:off x="4297680" y="1499616"/>
+            <a:ext cx="3657600" cy="2057400"/>
+          </a:xfrm>
+          <a:prstGeom prst="rect">
+            <a:avLst/>
+          </a:prstGeom>
+          <a:solidFill>
+            <a:srgbClr val="EEF2F8"/>
+          </a:solidFill>
+          <a:ln w="10160">
+            <a:solidFill>
+              <a:srgbClr val="1C3461"/>
+            </a:solidFill>
           </a:ln>
         </p:spPr>
         <p:style>
@@ -7283,49 +7247,116 @@
       </p:sp>
       <p:sp>
         <p:nvSpPr>
+          <p:cNvPr id="14" name="TextBox 13"/>
+          <p:cNvSpPr txBox="1"/>
+          <p:nvPr/>
+        </p:nvSpPr>
+        <p:spPr>
+          <a:xfrm>
+            <a:off x="4297680" y="1609344"/>
+            <a:ext cx="3657600" cy="822960"/>
+          </a:xfrm>
+          <a:prstGeom prst="rect">
+            <a:avLst/>
+          </a:prstGeom>
+          <a:noFill/>
+        </p:spPr>
+        <p:txBody>
+          <a:bodyPr wrap="square">
+            <a:spAutoFit/>
+          </a:bodyPr>
+          <a:lstStyle/>
+          <a:p>
+            <a:pPr algn="ctr"/>
+            <a:r>
+              <a:rPr sz="3200" b="1" i="0">
+                <a:solidFill>
+                  <a:srgbClr val="243D72"/>
+                </a:solidFill>
+              </a:rPr>
+              <a:t>600</a:t>
+            </a:r>
+          </a:p>
+        </p:txBody>
+      </p:sp>
+      <p:sp>
+        <p:nvSpPr>
           <p:cNvPr id="15" name="TextBox 14"/>
           <p:cNvSpPr txBox="1"/>
           <p:nvPr/>
         </p:nvSpPr>
         <p:spPr>
           <a:xfrm>
-            <a:off x="2002536" y="1444752"/>
-            <a:ext cx="1536192" cy="530352"/>
-          </a:xfrm>
-          <a:prstGeom prst="rect">
-            <a:avLst/>
-          </a:prstGeom>
-          <a:noFill/>
-        </p:spPr>
-        <p:txBody>
-          <a:bodyPr wrap="square">
-            <a:spAutoFit/>
-          </a:bodyPr>
-          <a:lstStyle/>
-          <a:p>
-            <a:pPr algn="ctr"/>
-            <a:r>
-              <a:rPr sz="900" b="1" i="0">
-                <a:solidFill>
-                  <a:srgbClr val="FFFFFF"/>
-                </a:solidFill>
-              </a:rPr>
-              <a:t>01:00
-–02:00</a:t>
-            </a:r>
-          </a:p>
-        </p:txBody>
-      </p:sp>
-      <p:sp>
-        <p:nvSpPr>
-          <p:cNvPr id="16" name="Rectangle 15"/>
+            <a:off x="4297680" y="2450592"/>
+            <a:ext cx="3657600" cy="365760"/>
+          </a:xfrm>
+          <a:prstGeom prst="rect">
+            <a:avLst/>
+          </a:prstGeom>
+          <a:noFill/>
+        </p:spPr>
+        <p:txBody>
+          <a:bodyPr wrap="square">
+            <a:spAutoFit/>
+          </a:bodyPr>
+          <a:lstStyle/>
+          <a:p>
+            <a:pPr algn="ctr"/>
+            <a:r>
+              <a:rPr sz="1300" b="1" i="0">
+                <a:solidFill>
+                  <a:srgbClr val="1C3461"/>
+                </a:solidFill>
+              </a:rPr>
+              <a:t>Indexed Incidents</a:t>
+            </a:r>
+          </a:p>
+        </p:txBody>
+      </p:sp>
+      <p:sp>
+        <p:nvSpPr>
+          <p:cNvPr id="16" name="TextBox 15"/>
+          <p:cNvSpPr txBox="1"/>
+          <p:nvPr/>
+        </p:nvSpPr>
+        <p:spPr>
+          <a:xfrm>
+            <a:off x="4389120" y="2862072"/>
+            <a:ext cx="3474720" cy="640080"/>
+          </a:xfrm>
+          <a:prstGeom prst="rect">
+            <a:avLst/>
+          </a:prstGeom>
+          <a:noFill/>
+        </p:spPr>
+        <p:txBody>
+          <a:bodyPr wrap="square">
+            <a:spAutoFit/>
+          </a:bodyPr>
+          <a:lstStyle/>
+          <a:p>
+            <a:pPr algn="ctr"/>
+            <a:r>
+              <a:rPr sz="1000" b="0" i="0">
+                <a:solidFill>
+                  <a:srgbClr val="6B7A9A"/>
+                </a:solidFill>
+              </a:rPr>
+              <a:t>2024–2026 synthetic supply chain records</a:t>
+            </a:r>
+          </a:p>
+        </p:txBody>
+      </p:sp>
+      <p:sp>
+        <p:nvSpPr>
+          <p:cNvPr id="17" name="Rectangle 16"/>
           <p:cNvSpPr/>
           <p:nvPr/>
         </p:nvSpPr>
         <p:spPr>
           <a:xfrm>
-            <a:off x="2002536" y="1975104"/>
-            <a:ext cx="1536192" cy="502920"/>
+            <a:off x="8229600" y="1444752"/>
+            <a:ext cx="3657600" cy="54864"/>
           </a:xfrm>
           <a:prstGeom prst="rect">
             <a:avLst/>
@@ -7361,49 +7392,14 @@
       </p:sp>
       <p:sp>
         <p:nvSpPr>
-          <p:cNvPr id="17" name="TextBox 16"/>
-          <p:cNvSpPr txBox="1"/>
-          <p:nvPr/>
-        </p:nvSpPr>
-        <p:spPr>
-          <a:xfrm>
-            <a:off x="2002536" y="1975104"/>
-            <a:ext cx="1536192" cy="502920"/>
-          </a:xfrm>
-          <a:prstGeom prst="rect">
-            <a:avLst/>
-          </a:prstGeom>
-          <a:noFill/>
-        </p:spPr>
-        <p:txBody>
-          <a:bodyPr wrap="square">
-            <a:spAutoFit/>
-          </a:bodyPr>
-          <a:lstStyle/>
-          <a:p>
-            <a:pPr algn="ctr"/>
-            <a:r>
-              <a:rPr sz="1000" b="1" i="0">
-                <a:solidFill>
-                  <a:srgbClr val="FFFFFF"/>
-                </a:solidFill>
-              </a:rPr>
-              <a:t>System
-Overview</a:t>
-            </a:r>
-          </a:p>
-        </p:txBody>
-      </p:sp>
-      <p:sp>
-        <p:nvSpPr>
           <p:cNvPr id="18" name="Rectangle 17"/>
           <p:cNvSpPr/>
           <p:nvPr/>
         </p:nvSpPr>
         <p:spPr>
           <a:xfrm>
-            <a:off x="2002536" y="2478024"/>
-            <a:ext cx="1536192" cy="4069080"/>
+            <a:off x="8229600" y="1499616"/>
+            <a:ext cx="3657600" cy="2057400"/>
           </a:xfrm>
           <a:prstGeom prst="rect">
             <a:avLst/>
@@ -7411,7 +7407,7 @@
           <a:solidFill>
             <a:srgbClr val="EEF2F8"/>
           </a:solidFill>
-          <a:ln w="12700">
+          <a:ln w="10160">
             <a:solidFill>
               <a:srgbClr val="1C3461"/>
             </a:solidFill>
@@ -7447,29 +7443,28 @@
         </p:nvSpPr>
         <p:spPr>
           <a:xfrm>
-            <a:off x="2075688" y="2578608"/>
-            <a:ext cx="1389888" cy="3840480"/>
-          </a:xfrm>
-          <a:prstGeom prst="rect">
-            <a:avLst/>
-          </a:prstGeom>
-          <a:noFill/>
-        </p:spPr>
-        <p:txBody>
-          <a:bodyPr wrap="square">
-            <a:spAutoFit/>
-          </a:bodyPr>
-          <a:lstStyle/>
-          <a:p>
-            <a:pPr algn="l"/>
-            <a:r>
-              <a:rPr sz="950" b="0" i="0">
-                <a:solidFill>
-                  <a:srgbClr val="1A2038"/>
-                </a:solidFill>
-              </a:rPr>
-              <a:t>Walk through architecture slide.
-Frontend → API → RAG → Agents → LLM.</a:t>
+            <a:off x="8229600" y="1609344"/>
+            <a:ext cx="3657600" cy="822960"/>
+          </a:xfrm>
+          <a:prstGeom prst="rect">
+            <a:avLst/>
+          </a:prstGeom>
+          <a:noFill/>
+        </p:spPr>
+        <p:txBody>
+          <a:bodyPr wrap="square">
+            <a:spAutoFit/>
+          </a:bodyPr>
+          <a:lstStyle/>
+          <a:p>
+            <a:pPr algn="ctr"/>
+            <a:r>
+              <a:rPr sz="3200" b="1" i="0">
+                <a:solidFill>
+                  <a:srgbClr val="F05A28"/>
+                </a:solidFill>
+              </a:rPr>
+              <a:t>30</a:t>
             </a:r>
           </a:p>
         </p:txBody>
@@ -7482,8 +7477,8 @@
         </p:nvSpPr>
         <p:spPr>
           <a:xfrm>
-            <a:off x="3584448" y="2606040"/>
-            <a:ext cx="146304" cy="365760"/>
+            <a:off x="8229600" y="2450592"/>
+            <a:ext cx="3657600" cy="365760"/>
           </a:xfrm>
           <a:prstGeom prst="rect">
             <a:avLst/>
@@ -7500,30 +7495,64 @@
             <a:r>
               <a:rPr sz="1300" b="1" i="0">
                 <a:solidFill>
-                  <a:srgbClr val="F05A28"/>
-                </a:solidFill>
-              </a:rPr>
-              <a:t>→</a:t>
-            </a:r>
-          </a:p>
-        </p:txBody>
-      </p:sp>
-      <p:sp>
-        <p:nvSpPr>
-          <p:cNvPr id="21" name="Rectangle 20"/>
+                  <a:srgbClr val="1C3461"/>
+                </a:solidFill>
+              </a:rPr>
+              <a:t>Anomalies Found</a:t>
+            </a:r>
+          </a:p>
+        </p:txBody>
+      </p:sp>
+      <p:sp>
+        <p:nvSpPr>
+          <p:cNvPr id="21" name="TextBox 20"/>
+          <p:cNvSpPr txBox="1"/>
+          <p:nvPr/>
+        </p:nvSpPr>
+        <p:spPr>
+          <a:xfrm>
+            <a:off x="8321040" y="2862072"/>
+            <a:ext cx="3474720" cy="640080"/>
+          </a:xfrm>
+          <a:prstGeom prst="rect">
+            <a:avLst/>
+          </a:prstGeom>
+          <a:noFill/>
+        </p:spPr>
+        <p:txBody>
+          <a:bodyPr wrap="square">
+            <a:spAutoFit/>
+          </a:bodyPr>
+          <a:lstStyle/>
+          <a:p>
+            <a:pPr algn="ctr"/>
+            <a:r>
+              <a:rPr sz="1000" b="0" i="0">
+                <a:solidFill>
+                  <a:srgbClr val="6B7A9A"/>
+                </a:solidFill>
+              </a:rPr>
+              <a:t>IsolationForest contamination=0.05</a:t>
+            </a:r>
+          </a:p>
+        </p:txBody>
+      </p:sp>
+      <p:sp>
+        <p:nvSpPr>
+          <p:cNvPr id="22" name="Rectangle 21"/>
           <p:cNvSpPr/>
           <p:nvPr/>
         </p:nvSpPr>
         <p:spPr>
           <a:xfrm>
-            <a:off x="3685032" y="1444752"/>
-            <a:ext cx="1536192" cy="530352"/>
-          </a:xfrm>
-          <a:prstGeom prst="rect">
-            <a:avLst/>
-          </a:prstGeom>
-          <a:solidFill>
-            <a:srgbClr val="243D72"/>
+            <a:off x="365760" y="3776472"/>
+            <a:ext cx="3657600" cy="54864"/>
+          </a:xfrm>
+          <a:prstGeom prst="rect">
+            <a:avLst/>
+          </a:prstGeom>
+          <a:solidFill>
+            <a:srgbClr val="C47A00"/>
           </a:solidFill>
           <a:ln>
             <a:noFill/>
@@ -7553,58 +7582,25 @@
       </p:sp>
       <p:sp>
         <p:nvSpPr>
-          <p:cNvPr id="22" name="TextBox 21"/>
-          <p:cNvSpPr txBox="1"/>
-          <p:nvPr/>
-        </p:nvSpPr>
-        <p:spPr>
-          <a:xfrm>
-            <a:off x="3685032" y="1444752"/>
-            <a:ext cx="1536192" cy="530352"/>
-          </a:xfrm>
-          <a:prstGeom prst="rect">
-            <a:avLst/>
-          </a:prstGeom>
-          <a:noFill/>
-        </p:spPr>
-        <p:txBody>
-          <a:bodyPr wrap="square">
-            <a:spAutoFit/>
-          </a:bodyPr>
-          <a:lstStyle/>
-          <a:p>
-            <a:pPr algn="ctr"/>
-            <a:r>
-              <a:rPr sz="900" b="1" i="0">
-                <a:solidFill>
-                  <a:srgbClr val="FFFFFF"/>
-                </a:solidFill>
-              </a:rPr>
-              <a:t>02:00
-–03:30</a:t>
-            </a:r>
-          </a:p>
-        </p:txBody>
-      </p:sp>
-      <p:sp>
-        <p:nvSpPr>
           <p:cNvPr id="23" name="Rectangle 22"/>
           <p:cNvSpPr/>
           <p:nvPr/>
         </p:nvSpPr>
         <p:spPr>
           <a:xfrm>
-            <a:off x="3685032" y="1975104"/>
-            <a:ext cx="1536192" cy="502920"/>
-          </a:xfrm>
-          <a:prstGeom prst="rect">
-            <a:avLst/>
-          </a:prstGeom>
-          <a:solidFill>
-            <a:srgbClr val="F05A28"/>
-          </a:solidFill>
-          <a:ln>
-            <a:noFill/>
+            <a:off x="365760" y="3831336"/>
+            <a:ext cx="3657600" cy="2057400"/>
+          </a:xfrm>
+          <a:prstGeom prst="rect">
+            <a:avLst/>
+          </a:prstGeom>
+          <a:solidFill>
+            <a:srgbClr val="EEF2F8"/>
+          </a:solidFill>
+          <a:ln w="10160">
+            <a:solidFill>
+              <a:srgbClr val="1C3461"/>
+            </a:solidFill>
           </a:ln>
         </p:spPr>
         <p:style>
@@ -7637,54 +7633,119 @@
         </p:nvSpPr>
         <p:spPr>
           <a:xfrm>
-            <a:off x="3685032" y="1975104"/>
-            <a:ext cx="1536192" cy="502920"/>
-          </a:xfrm>
-          <a:prstGeom prst="rect">
-            <a:avLst/>
-          </a:prstGeom>
-          <a:noFill/>
-        </p:spPr>
-        <p:txBody>
-          <a:bodyPr wrap="square">
-            <a:spAutoFit/>
-          </a:bodyPr>
-          <a:lstStyle/>
-          <a:p>
-            <a:pPr algn="ctr"/>
-            <a:r>
-              <a:rPr sz="1000" b="1" i="0">
-                <a:solidFill>
-                  <a:srgbClr val="FFFFFF"/>
-                </a:solidFill>
-              </a:rPr>
-              <a:t>Search
-Tab</a:t>
-            </a:r>
-          </a:p>
-        </p:txBody>
-      </p:sp>
-      <p:sp>
-        <p:nvSpPr>
-          <p:cNvPr id="25" name="Rectangle 24"/>
+            <a:off x="365760" y="3941064"/>
+            <a:ext cx="3657600" cy="822960"/>
+          </a:xfrm>
+          <a:prstGeom prst="rect">
+            <a:avLst/>
+          </a:prstGeom>
+          <a:noFill/>
+        </p:spPr>
+        <p:txBody>
+          <a:bodyPr wrap="square">
+            <a:spAutoFit/>
+          </a:bodyPr>
+          <a:lstStyle/>
+          <a:p>
+            <a:pPr algn="ctr"/>
+            <a:r>
+              <a:rPr sz="3200" b="1" i="0">
+                <a:solidFill>
+                  <a:srgbClr val="C47A00"/>
+                </a:solidFill>
+              </a:rPr>
+              <a:t>9.19d</a:t>
+            </a:r>
+          </a:p>
+        </p:txBody>
+      </p:sp>
+      <p:sp>
+        <p:nvSpPr>
+          <p:cNvPr id="25" name="TextBox 24"/>
+          <p:cNvSpPr txBox="1"/>
+          <p:nvPr/>
+        </p:nvSpPr>
+        <p:spPr>
+          <a:xfrm>
+            <a:off x="365760" y="4782312"/>
+            <a:ext cx="3657600" cy="365760"/>
+          </a:xfrm>
+          <a:prstGeom prst="rect">
+            <a:avLst/>
+          </a:prstGeom>
+          <a:noFill/>
+        </p:spPr>
+        <p:txBody>
+          <a:bodyPr wrap="square">
+            <a:spAutoFit/>
+          </a:bodyPr>
+          <a:lstStyle/>
+          <a:p>
+            <a:pPr algn="ctr"/>
+            <a:r>
+              <a:rPr sz="1300" b="1" i="0">
+                <a:solidFill>
+                  <a:srgbClr val="1C3461"/>
+                </a:solidFill>
+              </a:rPr>
+              <a:t>Avg Delivery Delay</a:t>
+            </a:r>
+          </a:p>
+        </p:txBody>
+      </p:sp>
+      <p:sp>
+        <p:nvSpPr>
+          <p:cNvPr id="26" name="TextBox 25"/>
+          <p:cNvSpPr txBox="1"/>
+          <p:nvPr/>
+        </p:nvSpPr>
+        <p:spPr>
+          <a:xfrm>
+            <a:off x="457200" y="5193792"/>
+            <a:ext cx="3474720" cy="640080"/>
+          </a:xfrm>
+          <a:prstGeom prst="rect">
+            <a:avLst/>
+          </a:prstGeom>
+          <a:noFill/>
+        </p:spPr>
+        <p:txBody>
+          <a:bodyPr wrap="square">
+            <a:spAutoFit/>
+          </a:bodyPr>
+          <a:lstStyle/>
+          <a:p>
+            <a:pPr algn="ctr"/>
+            <a:r>
+              <a:rPr sz="1000" b="0" i="0">
+                <a:solidFill>
+                  <a:srgbClr val="6B7A9A"/>
+                </a:solidFill>
+              </a:rPr>
+              <a:t>Across all incidents (deteriorating trend)</a:t>
+            </a:r>
+          </a:p>
+        </p:txBody>
+      </p:sp>
+      <p:sp>
+        <p:nvSpPr>
+          <p:cNvPr id="27" name="Rectangle 26"/>
           <p:cNvSpPr/>
           <p:nvPr/>
         </p:nvSpPr>
         <p:spPr>
           <a:xfrm>
-            <a:off x="3685032" y="2478024"/>
-            <a:ext cx="1536192" cy="4069080"/>
-          </a:xfrm>
-          <a:prstGeom prst="rect">
-            <a:avLst/>
-          </a:prstGeom>
-          <a:solidFill>
-            <a:srgbClr val="EEF2F8"/>
-          </a:solidFill>
-          <a:ln w="12700">
-            <a:solidFill>
-              <a:srgbClr val="243D72"/>
-            </a:solidFill>
+            <a:off x="4297680" y="3776472"/>
+            <a:ext cx="3657600" cy="54864"/>
+          </a:xfrm>
+          <a:prstGeom prst="rect">
+            <a:avLst/>
+          </a:prstGeom>
+          <a:solidFill>
+            <a:srgbClr val="C8201A"/>
+          </a:solidFill>
+          <a:ln>
+            <a:noFill/>
           </a:ln>
         </p:spPr>
         <p:style>
@@ -7711,92 +7772,25 @@
       </p:sp>
       <p:sp>
         <p:nvSpPr>
-          <p:cNvPr id="26" name="TextBox 25"/>
-          <p:cNvSpPr txBox="1"/>
-          <p:nvPr/>
-        </p:nvSpPr>
-        <p:spPr>
-          <a:xfrm>
-            <a:off x="3758184" y="2578608"/>
-            <a:ext cx="1389888" cy="3840480"/>
-          </a:xfrm>
-          <a:prstGeom prst="rect">
-            <a:avLst/>
-          </a:prstGeom>
-          <a:noFill/>
-        </p:spPr>
-        <p:txBody>
-          <a:bodyPr wrap="square">
-            <a:spAutoFit/>
-          </a:bodyPr>
-          <a:lstStyle/>
-          <a:p>
-            <a:pPr algn="l"/>
-            <a:r>
-              <a:rPr sz="950" b="0" i="0">
-                <a:solidFill>
-                  <a:srgbClr val="1A2038"/>
-                </a:solidFill>
-              </a:rPr>
-              <a:t>Query: 'supplier delivery delays for critical components'
-Show hybrid results, severity chips, latency 40ms.</a:t>
-            </a:r>
-          </a:p>
-        </p:txBody>
-      </p:sp>
-      <p:sp>
-        <p:nvSpPr>
-          <p:cNvPr id="27" name="TextBox 26"/>
-          <p:cNvSpPr txBox="1"/>
-          <p:nvPr/>
-        </p:nvSpPr>
-        <p:spPr>
-          <a:xfrm>
-            <a:off x="5266944" y="2606040"/>
-            <a:ext cx="146304" cy="365760"/>
-          </a:xfrm>
-          <a:prstGeom prst="rect">
-            <a:avLst/>
-          </a:prstGeom>
-          <a:noFill/>
-        </p:spPr>
-        <p:txBody>
-          <a:bodyPr wrap="square">
-            <a:spAutoFit/>
-          </a:bodyPr>
-          <a:lstStyle/>
-          <a:p>
-            <a:pPr algn="ctr"/>
-            <a:r>
-              <a:rPr sz="1300" b="1" i="0">
-                <a:solidFill>
-                  <a:srgbClr val="F05A28"/>
-                </a:solidFill>
-              </a:rPr>
-              <a:t>→</a:t>
-            </a:r>
-          </a:p>
-        </p:txBody>
-      </p:sp>
-      <p:sp>
-        <p:nvSpPr>
           <p:cNvPr id="28" name="Rectangle 27"/>
           <p:cNvSpPr/>
           <p:nvPr/>
         </p:nvSpPr>
         <p:spPr>
           <a:xfrm>
-            <a:off x="5367528" y="1444752"/>
-            <a:ext cx="1536192" cy="530352"/>
-          </a:xfrm>
-          <a:prstGeom prst="rect">
-            <a:avLst/>
-          </a:prstGeom>
-          <a:solidFill>
-            <a:srgbClr val="F05A28"/>
-          </a:solidFill>
-          <a:ln>
-            <a:noFill/>
+            <a:off x="4297680" y="3831336"/>
+            <a:ext cx="3657600" cy="2057400"/>
+          </a:xfrm>
+          <a:prstGeom prst="rect">
+            <a:avLst/>
+          </a:prstGeom>
+          <a:solidFill>
+            <a:srgbClr val="EEF2F8"/>
+          </a:solidFill>
+          <a:ln w="10160">
+            <a:solidFill>
+              <a:srgbClr val="1C3461"/>
+            </a:solidFill>
           </a:ln>
         </p:spPr>
         <p:style>
@@ -7829,49 +7823,116 @@
         </p:nvSpPr>
         <p:spPr>
           <a:xfrm>
-            <a:off x="5367528" y="1444752"/>
-            <a:ext cx="1536192" cy="530352"/>
-          </a:xfrm>
-          <a:prstGeom prst="rect">
-            <a:avLst/>
-          </a:prstGeom>
-          <a:noFill/>
-        </p:spPr>
-        <p:txBody>
-          <a:bodyPr wrap="square">
-            <a:spAutoFit/>
-          </a:bodyPr>
-          <a:lstStyle/>
-          <a:p>
-            <a:pPr algn="ctr"/>
-            <a:r>
-              <a:rPr sz="900" b="1" i="0">
-                <a:solidFill>
-                  <a:srgbClr val="FFFFFF"/>
-                </a:solidFill>
-              </a:rPr>
-              <a:t>03:30
-–05:30</a:t>
-            </a:r>
-          </a:p>
-        </p:txBody>
-      </p:sp>
-      <p:sp>
-        <p:nvSpPr>
-          <p:cNvPr id="30" name="Rectangle 29"/>
+            <a:off x="4297680" y="3941064"/>
+            <a:ext cx="3657600" cy="822960"/>
+          </a:xfrm>
+          <a:prstGeom prst="rect">
+            <a:avLst/>
+          </a:prstGeom>
+          <a:noFill/>
+        </p:spPr>
+        <p:txBody>
+          <a:bodyPr wrap="square">
+            <a:spAutoFit/>
+          </a:bodyPr>
+          <a:lstStyle/>
+          <a:p>
+            <a:pPr algn="ctr"/>
+            <a:r>
+              <a:rPr sz="3200" b="1" i="0">
+                <a:solidFill>
+                  <a:srgbClr val="C8201A"/>
+                </a:solidFill>
+              </a:rPr>
+              <a:t>302</a:t>
+            </a:r>
+          </a:p>
+        </p:txBody>
+      </p:sp>
+      <p:sp>
+        <p:nvSpPr>
+          <p:cNvPr id="30" name="TextBox 29"/>
+          <p:cNvSpPr txBox="1"/>
+          <p:nvPr/>
+        </p:nvSpPr>
+        <p:spPr>
+          <a:xfrm>
+            <a:off x="4297680" y="4782312"/>
+            <a:ext cx="3657600" cy="365760"/>
+          </a:xfrm>
+          <a:prstGeom prst="rect">
+            <a:avLst/>
+          </a:prstGeom>
+          <a:noFill/>
+        </p:spPr>
+        <p:txBody>
+          <a:bodyPr wrap="square">
+            <a:spAutoFit/>
+          </a:bodyPr>
+          <a:lstStyle/>
+          <a:p>
+            <a:pPr algn="ctr"/>
+            <a:r>
+              <a:rPr sz="1300" b="1" i="0">
+                <a:solidFill>
+                  <a:srgbClr val="1C3461"/>
+                </a:solidFill>
+              </a:rPr>
+              <a:t>Critical Incidents</a:t>
+            </a:r>
+          </a:p>
+        </p:txBody>
+      </p:sp>
+      <p:sp>
+        <p:nvSpPr>
+          <p:cNvPr id="31" name="TextBox 30"/>
+          <p:cNvSpPr txBox="1"/>
+          <p:nvPr/>
+        </p:nvSpPr>
+        <p:spPr>
+          <a:xfrm>
+            <a:off x="4389120" y="5193792"/>
+            <a:ext cx="3474720" cy="640080"/>
+          </a:xfrm>
+          <a:prstGeom prst="rect">
+            <a:avLst/>
+          </a:prstGeom>
+          <a:noFill/>
+        </p:spPr>
+        <p:txBody>
+          <a:bodyPr wrap="square">
+            <a:spAutoFit/>
+          </a:bodyPr>
+          <a:lstStyle/>
+          <a:p>
+            <a:pPr algn="ctr"/>
+            <a:r>
+              <a:rPr sz="1000" b="0" i="0">
+                <a:solidFill>
+                  <a:srgbClr val="6B7A9A"/>
+                </a:solidFill>
+              </a:rPr>
+              <a:t>50.3% of corpus flagged as critical severity</a:t>
+            </a:r>
+          </a:p>
+        </p:txBody>
+      </p:sp>
+      <p:sp>
+        <p:nvSpPr>
+          <p:cNvPr id="32" name="Rectangle 31"/>
           <p:cNvSpPr/>
           <p:nvPr/>
         </p:nvSpPr>
         <p:spPr>
           <a:xfrm>
-            <a:off x="5367528" y="1975104"/>
-            <a:ext cx="1536192" cy="502920"/>
-          </a:xfrm>
-          <a:prstGeom prst="rect">
-            <a:avLst/>
-          </a:prstGeom>
-          <a:solidFill>
-            <a:srgbClr val="F05A28"/>
+            <a:off x="8229600" y="3776472"/>
+            <a:ext cx="3657600" cy="54864"/>
+          </a:xfrm>
+          <a:prstGeom prst="rect">
+            <a:avLst/>
+          </a:prstGeom>
+          <a:solidFill>
+            <a:srgbClr val="0A7A4A"/>
           </a:solidFill>
           <a:ln>
             <a:noFill/>
@@ -7901,49 +7962,14 @@
       </p:sp>
       <p:sp>
         <p:nvSpPr>
-          <p:cNvPr id="31" name="TextBox 30"/>
-          <p:cNvSpPr txBox="1"/>
-          <p:nvPr/>
-        </p:nvSpPr>
-        <p:spPr>
-          <a:xfrm>
-            <a:off x="5367528" y="1975104"/>
-            <a:ext cx="1536192" cy="502920"/>
-          </a:xfrm>
-          <a:prstGeom prst="rect">
-            <a:avLst/>
-          </a:prstGeom>
-          <a:noFill/>
-        </p:spPr>
-        <p:txBody>
-          <a:bodyPr wrap="square">
-            <a:spAutoFit/>
-          </a:bodyPr>
-          <a:lstStyle/>
-          <a:p>
-            <a:pPr algn="ctr"/>
-            <a:r>
-              <a:rPr sz="1000" b="1" i="0">
-                <a:solidFill>
-                  <a:srgbClr val="FFFFFF"/>
-                </a:solidFill>
-              </a:rPr>
-              <a:t>Recommendations
-Tab</a:t>
-            </a:r>
-          </a:p>
-        </p:txBody>
-      </p:sp>
-      <p:sp>
-        <p:nvSpPr>
-          <p:cNvPr id="32" name="Rectangle 31"/>
+          <p:cNvPr id="33" name="Rectangle 32"/>
           <p:cNvSpPr/>
           <p:nvPr/>
         </p:nvSpPr>
         <p:spPr>
           <a:xfrm>
-            <a:off x="5367528" y="2478024"/>
-            <a:ext cx="1536192" cy="4069080"/>
+            <a:off x="8229600" y="3831336"/>
+            <a:ext cx="3657600" cy="2057400"/>
           </a:xfrm>
           <a:prstGeom prst="rect">
             <a:avLst/>
@@ -7951,9 +7977,9 @@
           <a:solidFill>
             <a:srgbClr val="EEF2F8"/>
           </a:solidFill>
-          <a:ln w="12700">
+          <a:ln w="10160">
             <a:solidFill>
-              <a:srgbClr val="F05A28"/>
+              <a:srgbClr val="1C3461"/>
             </a:solidFill>
           </a:ln>
         </p:spPr>
@@ -7981,49 +8007,48 @@
       </p:sp>
       <p:sp>
         <p:nvSpPr>
-          <p:cNvPr id="33" name="TextBox 32"/>
-          <p:cNvSpPr txBox="1"/>
-          <p:nvPr/>
-        </p:nvSpPr>
-        <p:spPr>
-          <a:xfrm>
-            <a:off x="5440680" y="2578608"/>
-            <a:ext cx="1389888" cy="3840480"/>
-          </a:xfrm>
-          <a:prstGeom prst="rect">
-            <a:avLst/>
-          </a:prstGeom>
-          <a:noFill/>
-        </p:spPr>
-        <p:txBody>
-          <a:bodyPr wrap="square">
-            <a:spAutoFit/>
-          </a:bodyPr>
-          <a:lstStyle/>
-          <a:p>
-            <a:pPr algn="l"/>
-            <a:r>
-              <a:rPr sz="950" b="0" i="0">
-                <a:solidFill>
-                  <a:srgbClr val="1A2038"/>
-                </a:solidFill>
-              </a:rPr>
-              <a:t>Query: 'port congestion impacting shipment schedules'
-Highlight animated risk bars + 5 priority mitigations.</a:t>
-            </a:r>
-          </a:p>
-        </p:txBody>
-      </p:sp>
-      <p:sp>
-        <p:nvSpPr>
           <p:cNvPr id="34" name="TextBox 33"/>
           <p:cNvSpPr txBox="1"/>
           <p:nvPr/>
         </p:nvSpPr>
         <p:spPr>
           <a:xfrm>
-            <a:off x="6949440" y="2606040"/>
-            <a:ext cx="146304" cy="365760"/>
+            <a:off x="8229600" y="3941064"/>
+            <a:ext cx="3657600" cy="822960"/>
+          </a:xfrm>
+          <a:prstGeom prst="rect">
+            <a:avLst/>
+          </a:prstGeom>
+          <a:noFill/>
+        </p:spPr>
+        <p:txBody>
+          <a:bodyPr wrap="square">
+            <a:spAutoFit/>
+          </a:bodyPr>
+          <a:lstStyle/>
+          <a:p>
+            <a:pPr algn="ctr"/>
+            <a:r>
+              <a:rPr sz="3200" b="1" i="0">
+                <a:solidFill>
+                  <a:srgbClr val="0A7A4A"/>
+                </a:solidFill>
+              </a:rPr>
+              <a:t>4 Agents</a:t>
+            </a:r>
+          </a:p>
+        </p:txBody>
+      </p:sp>
+      <p:sp>
+        <p:nvSpPr>
+          <p:cNvPr id="35" name="TextBox 34"/>
+          <p:cNvSpPr txBox="1"/>
+          <p:nvPr/>
+        </p:nvSpPr>
+        <p:spPr>
+          <a:xfrm>
+            <a:off x="8229600" y="4782312"/>
+            <a:ext cx="3657600" cy="365760"/>
           </a:xfrm>
           <a:prstGeom prst="rect">
             <a:avLst/>
@@ -8040,54 +8065,11 @@
             <a:r>
               <a:rPr sz="1300" b="1" i="0">
                 <a:solidFill>
-                  <a:srgbClr val="F05A28"/>
-                </a:solidFill>
-              </a:rPr>
-              <a:t>→</a:t>
-            </a:r>
-          </a:p>
-        </p:txBody>
-      </p:sp>
-      <p:sp>
-        <p:nvSpPr>
-          <p:cNvPr id="35" name="Rectangle 34"/>
-          <p:cNvSpPr/>
-          <p:nvPr/>
-        </p:nvSpPr>
-        <p:spPr>
-          <a:xfrm>
-            <a:off x="7050024" y="1444752"/>
-            <a:ext cx="1536192" cy="530352"/>
-          </a:xfrm>
-          <a:prstGeom prst="rect">
-            <a:avLst/>
-          </a:prstGeom>
-          <a:solidFill>
-            <a:srgbClr val="2E4A80"/>
-          </a:solidFill>
-          <a:ln>
-            <a:noFill/>
-          </a:ln>
-        </p:spPr>
-        <p:style>
-          <a:lnRef idx="1">
-            <a:schemeClr val="accent1"/>
-          </a:lnRef>
-          <a:fillRef idx="3">
-            <a:schemeClr val="accent1"/>
-          </a:fillRef>
-          <a:effectRef idx="2">
-            <a:schemeClr val="accent1"/>
-          </a:effectRef>
-          <a:fontRef idx="minor">
-            <a:schemeClr val="lt1"/>
-          </a:fontRef>
-        </p:style>
-        <p:txBody>
-          <a:bodyPr rtlCol="0" anchor="ctr"/>
-          <a:lstStyle/>
-          <a:p>
-            <a:pPr algn="ctr"/>
+                  <a:srgbClr val="1C3461"/>
+                </a:solidFill>
+              </a:rPr>
+              <a:t>Multi-Agent</a:t>
+            </a:r>
           </a:p>
         </p:txBody>
       </p:sp>
@@ -8099,727 +8081,28 @@
         </p:nvSpPr>
         <p:spPr>
           <a:xfrm>
-            <a:off x="7050024" y="1444752"/>
-            <a:ext cx="1536192" cy="530352"/>
-          </a:xfrm>
-          <a:prstGeom prst="rect">
-            <a:avLst/>
-          </a:prstGeom>
-          <a:noFill/>
-        </p:spPr>
-        <p:txBody>
-          <a:bodyPr wrap="square">
-            <a:spAutoFit/>
-          </a:bodyPr>
-          <a:lstStyle/>
-          <a:p>
-            <a:pPr algn="ctr"/>
-            <a:r>
-              <a:rPr sz="900" b="1" i="0">
-                <a:solidFill>
-                  <a:srgbClr val="FFFFFF"/>
-                </a:solidFill>
-              </a:rPr>
-              <a:t>05:30
-–07:30</a:t>
-            </a:r>
-          </a:p>
-        </p:txBody>
-      </p:sp>
-      <p:sp>
-        <p:nvSpPr>
-          <p:cNvPr id="37" name="Rectangle 36"/>
-          <p:cNvSpPr/>
-          <p:nvPr/>
-        </p:nvSpPr>
-        <p:spPr>
-          <a:xfrm>
-            <a:off x="7050024" y="1975104"/>
-            <a:ext cx="1536192" cy="502920"/>
-          </a:xfrm>
-          <a:prstGeom prst="rect">
-            <a:avLst/>
-          </a:prstGeom>
-          <a:solidFill>
-            <a:srgbClr val="F05A28"/>
-          </a:solidFill>
-          <a:ln>
-            <a:noFill/>
-          </a:ln>
-        </p:spPr>
-        <p:style>
-          <a:lnRef idx="1">
-            <a:schemeClr val="accent1"/>
-          </a:lnRef>
-          <a:fillRef idx="3">
-            <a:schemeClr val="accent1"/>
-          </a:fillRef>
-          <a:effectRef idx="2">
-            <a:schemeClr val="accent1"/>
-          </a:effectRef>
-          <a:fontRef idx="minor">
-            <a:schemeClr val="lt1"/>
-          </a:fontRef>
-        </p:style>
-        <p:txBody>
-          <a:bodyPr rtlCol="0" anchor="ctr"/>
-          <a:lstStyle/>
-          <a:p>
-            <a:pPr algn="ctr"/>
-          </a:p>
-        </p:txBody>
-      </p:sp>
-      <p:sp>
-        <p:nvSpPr>
-          <p:cNvPr id="38" name="TextBox 37"/>
-          <p:cNvSpPr txBox="1"/>
-          <p:nvPr/>
-        </p:nvSpPr>
-        <p:spPr>
-          <a:xfrm>
-            <a:off x="7050024" y="1975104"/>
-            <a:ext cx="1536192" cy="502920"/>
-          </a:xfrm>
-          <a:prstGeom prst="rect">
-            <a:avLst/>
-          </a:prstGeom>
-          <a:noFill/>
-        </p:spPr>
-        <p:txBody>
-          <a:bodyPr wrap="square">
-            <a:spAutoFit/>
-          </a:bodyPr>
-          <a:lstStyle/>
-          <a:p>
-            <a:pPr algn="ctr"/>
-            <a:r>
-              <a:rPr sz="1000" b="1" i="0">
-                <a:solidFill>
-                  <a:srgbClr val="FFFFFF"/>
-                </a:solidFill>
-              </a:rPr>
-              <a:t>Multi-Agent
-Tab</a:t>
-            </a:r>
-          </a:p>
-        </p:txBody>
-      </p:sp>
-      <p:sp>
-        <p:nvSpPr>
-          <p:cNvPr id="39" name="Rectangle 38"/>
-          <p:cNvSpPr/>
-          <p:nvPr/>
-        </p:nvSpPr>
-        <p:spPr>
-          <a:xfrm>
-            <a:off x="7050024" y="2478024"/>
-            <a:ext cx="1536192" cy="4069080"/>
-          </a:xfrm>
-          <a:prstGeom prst="rect">
-            <a:avLst/>
-          </a:prstGeom>
-          <a:solidFill>
-            <a:srgbClr val="EEF2F8"/>
-          </a:solidFill>
-          <a:ln w="12700">
-            <a:solidFill>
-              <a:srgbClr val="2E4A80"/>
-            </a:solidFill>
-          </a:ln>
-        </p:spPr>
-        <p:style>
-          <a:lnRef idx="1">
-            <a:schemeClr val="accent1"/>
-          </a:lnRef>
-          <a:fillRef idx="3">
-            <a:schemeClr val="accent1"/>
-          </a:fillRef>
-          <a:effectRef idx="2">
-            <a:schemeClr val="accent1"/>
-          </a:effectRef>
-          <a:fontRef idx="minor">
-            <a:schemeClr val="lt1"/>
-          </a:fontRef>
-        </p:style>
-        <p:txBody>
-          <a:bodyPr rtlCol="0" anchor="ctr"/>
-          <a:lstStyle/>
-          <a:p>
-            <a:pPr algn="ctr"/>
-          </a:p>
-        </p:txBody>
-      </p:sp>
-      <p:sp>
-        <p:nvSpPr>
-          <p:cNvPr id="40" name="TextBox 39"/>
-          <p:cNvSpPr txBox="1"/>
-          <p:nvPr/>
-        </p:nvSpPr>
-        <p:spPr>
-          <a:xfrm>
-            <a:off x="7123176" y="2578608"/>
-            <a:ext cx="1389888" cy="3840480"/>
-          </a:xfrm>
-          <a:prstGeom prst="rect">
-            <a:avLst/>
-          </a:prstGeom>
-          <a:noFill/>
-        </p:spPr>
-        <p:txBody>
-          <a:bodyPr wrap="square">
-            <a:spAutoFit/>
-          </a:bodyPr>
-          <a:lstStyle/>
-          <a:p>
-            <a:pPr algn="l"/>
-            <a:r>
-              <a:rPr sz="950" b="0" i="0">
-                <a:solidFill>
-                  <a:srgbClr val="1A2038"/>
-                </a:solidFill>
-              </a:rPr>
-              <a:t>Query: 'warehouse inventory approaching stockout'
-Show 4 agent cards · A2A escalation chain · Alerts.</a:t>
-            </a:r>
-          </a:p>
-        </p:txBody>
-      </p:sp>
-      <p:sp>
-        <p:nvSpPr>
-          <p:cNvPr id="41" name="TextBox 40"/>
-          <p:cNvSpPr txBox="1"/>
-          <p:nvPr/>
-        </p:nvSpPr>
-        <p:spPr>
-          <a:xfrm>
-            <a:off x="8631936" y="2606040"/>
-            <a:ext cx="146304" cy="365760"/>
-          </a:xfrm>
-          <a:prstGeom prst="rect">
-            <a:avLst/>
-          </a:prstGeom>
-          <a:noFill/>
-        </p:spPr>
-        <p:txBody>
-          <a:bodyPr wrap="square">
-            <a:spAutoFit/>
-          </a:bodyPr>
-          <a:lstStyle/>
-          <a:p>
-            <a:pPr algn="ctr"/>
-            <a:r>
-              <a:rPr sz="1300" b="1" i="0">
-                <a:solidFill>
-                  <a:srgbClr val="F05A28"/>
-                </a:solidFill>
-              </a:rPr>
-              <a:t>→</a:t>
-            </a:r>
-          </a:p>
-        </p:txBody>
-      </p:sp>
-      <p:sp>
-        <p:nvSpPr>
-          <p:cNvPr id="42" name="Rectangle 41"/>
-          <p:cNvSpPr/>
-          <p:nvPr/>
-        </p:nvSpPr>
-        <p:spPr>
-          <a:xfrm>
-            <a:off x="8732520" y="1444752"/>
-            <a:ext cx="1536192" cy="530352"/>
-          </a:xfrm>
-          <a:prstGeom prst="rect">
-            <a:avLst/>
-          </a:prstGeom>
-          <a:solidFill>
-            <a:srgbClr val="C8201A"/>
-          </a:solidFill>
-          <a:ln>
-            <a:noFill/>
-          </a:ln>
-        </p:spPr>
-        <p:style>
-          <a:lnRef idx="1">
-            <a:schemeClr val="accent1"/>
-          </a:lnRef>
-          <a:fillRef idx="3">
-            <a:schemeClr val="accent1"/>
-          </a:fillRef>
-          <a:effectRef idx="2">
-            <a:schemeClr val="accent1"/>
-          </a:effectRef>
-          <a:fontRef idx="minor">
-            <a:schemeClr val="lt1"/>
-          </a:fontRef>
-        </p:style>
-        <p:txBody>
-          <a:bodyPr rtlCol="0" anchor="ctr"/>
-          <a:lstStyle/>
-          <a:p>
-            <a:pPr algn="ctr"/>
-          </a:p>
-        </p:txBody>
-      </p:sp>
-      <p:sp>
-        <p:nvSpPr>
-          <p:cNvPr id="43" name="TextBox 42"/>
-          <p:cNvSpPr txBox="1"/>
-          <p:nvPr/>
-        </p:nvSpPr>
-        <p:spPr>
-          <a:xfrm>
-            <a:off x="8732520" y="1444752"/>
-            <a:ext cx="1536192" cy="530352"/>
-          </a:xfrm>
-          <a:prstGeom prst="rect">
-            <a:avLst/>
-          </a:prstGeom>
-          <a:noFill/>
-        </p:spPr>
-        <p:txBody>
-          <a:bodyPr wrap="square">
-            <a:spAutoFit/>
-          </a:bodyPr>
-          <a:lstStyle/>
-          <a:p>
-            <a:pPr algn="ctr"/>
-            <a:r>
-              <a:rPr sz="900" b="1" i="0">
-                <a:solidFill>
-                  <a:srgbClr val="FFFFFF"/>
-                </a:solidFill>
-              </a:rPr>
-              <a:t>07:30
-–08:30</a:t>
-            </a:r>
-          </a:p>
-        </p:txBody>
-      </p:sp>
-      <p:sp>
-        <p:nvSpPr>
-          <p:cNvPr id="44" name="Rectangle 43"/>
-          <p:cNvSpPr/>
-          <p:nvPr/>
-        </p:nvSpPr>
-        <p:spPr>
-          <a:xfrm>
-            <a:off x="8732520" y="1975104"/>
-            <a:ext cx="1536192" cy="502920"/>
-          </a:xfrm>
-          <a:prstGeom prst="rect">
-            <a:avLst/>
-          </a:prstGeom>
-          <a:solidFill>
-            <a:srgbClr val="F05A28"/>
-          </a:solidFill>
-          <a:ln>
-            <a:noFill/>
-          </a:ln>
-        </p:spPr>
-        <p:style>
-          <a:lnRef idx="1">
-            <a:schemeClr val="accent1"/>
-          </a:lnRef>
-          <a:fillRef idx="3">
-            <a:schemeClr val="accent1"/>
-          </a:fillRef>
-          <a:effectRef idx="2">
-            <a:schemeClr val="accent1"/>
-          </a:effectRef>
-          <a:fontRef idx="minor">
-            <a:schemeClr val="lt1"/>
-          </a:fontRef>
-        </p:style>
-        <p:txBody>
-          <a:bodyPr rtlCol="0" anchor="ctr"/>
-          <a:lstStyle/>
-          <a:p>
-            <a:pPr algn="ctr"/>
-          </a:p>
-        </p:txBody>
-      </p:sp>
-      <p:sp>
-        <p:nvSpPr>
-          <p:cNvPr id="45" name="TextBox 44"/>
-          <p:cNvSpPr txBox="1"/>
-          <p:nvPr/>
-        </p:nvSpPr>
-        <p:spPr>
-          <a:xfrm>
-            <a:off x="8732520" y="1975104"/>
-            <a:ext cx="1536192" cy="502920"/>
-          </a:xfrm>
-          <a:prstGeom prst="rect">
-            <a:avLst/>
-          </a:prstGeom>
-          <a:noFill/>
-        </p:spPr>
-        <p:txBody>
-          <a:bodyPr wrap="square">
-            <a:spAutoFit/>
-          </a:bodyPr>
-          <a:lstStyle/>
-          <a:p>
-            <a:pPr algn="ctr"/>
-            <a:r>
-              <a:rPr sz="1000" b="1" i="0">
-                <a:solidFill>
-                  <a:srgbClr val="FFFFFF"/>
-                </a:solidFill>
-              </a:rPr>
-              <a:t>Dashboard &amp;
-Anomalies</a:t>
-            </a:r>
-          </a:p>
-        </p:txBody>
-      </p:sp>
-      <p:sp>
-        <p:nvSpPr>
-          <p:cNvPr id="46" name="Rectangle 45"/>
-          <p:cNvSpPr/>
-          <p:nvPr/>
-        </p:nvSpPr>
-        <p:spPr>
-          <a:xfrm>
-            <a:off x="8732520" y="2478024"/>
-            <a:ext cx="1536192" cy="4069080"/>
-          </a:xfrm>
-          <a:prstGeom prst="rect">
-            <a:avLst/>
-          </a:prstGeom>
-          <a:solidFill>
-            <a:srgbClr val="EEF2F8"/>
-          </a:solidFill>
-          <a:ln w="12700">
-            <a:solidFill>
-              <a:srgbClr val="C8201A"/>
-            </a:solidFill>
-          </a:ln>
-        </p:spPr>
-        <p:style>
-          <a:lnRef idx="1">
-            <a:schemeClr val="accent1"/>
-          </a:lnRef>
-          <a:fillRef idx="3">
-            <a:schemeClr val="accent1"/>
-          </a:fillRef>
-          <a:effectRef idx="2">
-            <a:schemeClr val="accent1"/>
-          </a:effectRef>
-          <a:fontRef idx="minor">
-            <a:schemeClr val="lt1"/>
-          </a:fontRef>
-        </p:style>
-        <p:txBody>
-          <a:bodyPr rtlCol="0" anchor="ctr"/>
-          <a:lstStyle/>
-          <a:p>
-            <a:pPr algn="ctr"/>
-          </a:p>
-        </p:txBody>
-      </p:sp>
-      <p:sp>
-        <p:nvSpPr>
-          <p:cNvPr id="47" name="TextBox 46"/>
-          <p:cNvSpPr txBox="1"/>
-          <p:nvPr/>
-        </p:nvSpPr>
-        <p:spPr>
-          <a:xfrm>
-            <a:off x="8805672" y="2578608"/>
-            <a:ext cx="1389888" cy="3840480"/>
-          </a:xfrm>
-          <a:prstGeom prst="rect">
-            <a:avLst/>
-          </a:prstGeom>
-          <a:noFill/>
-        </p:spPr>
-        <p:txBody>
-          <a:bodyPr wrap="square">
-            <a:spAutoFit/>
-          </a:bodyPr>
-          <a:lstStyle/>
-          <a:p>
-            <a:pPr algn="l"/>
-            <a:r>
-              <a:rPr sz="950" b="0" i="0">
-                <a:solidFill>
-                  <a:srgbClr val="1A2038"/>
-                </a:solidFill>
-              </a:rPr>
-              <a:t>KPI grid: 600 incidents · 302 critical · Deteriorating.
-Anomaly cards with Z-score attribution.</a:t>
-            </a:r>
-          </a:p>
-        </p:txBody>
-      </p:sp>
-      <p:sp>
-        <p:nvSpPr>
-          <p:cNvPr id="48" name="TextBox 47"/>
-          <p:cNvSpPr txBox="1"/>
-          <p:nvPr/>
-        </p:nvSpPr>
-        <p:spPr>
-          <a:xfrm>
-            <a:off x="10314432" y="2606040"/>
-            <a:ext cx="146304" cy="365760"/>
-          </a:xfrm>
-          <a:prstGeom prst="rect">
-            <a:avLst/>
-          </a:prstGeom>
-          <a:noFill/>
-        </p:spPr>
-        <p:txBody>
-          <a:bodyPr wrap="square">
-            <a:spAutoFit/>
-          </a:bodyPr>
-          <a:lstStyle/>
-          <a:p>
-            <a:pPr algn="ctr"/>
-            <a:r>
-              <a:rPr sz="1300" b="1" i="0">
-                <a:solidFill>
-                  <a:srgbClr val="F05A28"/>
-                </a:solidFill>
-              </a:rPr>
-              <a:t>→</a:t>
-            </a:r>
-          </a:p>
-        </p:txBody>
-      </p:sp>
-      <p:sp>
-        <p:nvSpPr>
-          <p:cNvPr id="49" name="Rectangle 48"/>
-          <p:cNvSpPr/>
-          <p:nvPr/>
-        </p:nvSpPr>
-        <p:spPr>
-          <a:xfrm>
-            <a:off x="10415016" y="1444752"/>
-            <a:ext cx="1536192" cy="530352"/>
-          </a:xfrm>
-          <a:prstGeom prst="rect">
-            <a:avLst/>
-          </a:prstGeom>
-          <a:solidFill>
-            <a:srgbClr val="0A7A4A"/>
-          </a:solidFill>
-          <a:ln>
-            <a:noFill/>
-          </a:ln>
-        </p:spPr>
-        <p:style>
-          <a:lnRef idx="1">
-            <a:schemeClr val="accent1"/>
-          </a:lnRef>
-          <a:fillRef idx="3">
-            <a:schemeClr val="accent1"/>
-          </a:fillRef>
-          <a:effectRef idx="2">
-            <a:schemeClr val="accent1"/>
-          </a:effectRef>
-          <a:fontRef idx="minor">
-            <a:schemeClr val="lt1"/>
-          </a:fontRef>
-        </p:style>
-        <p:txBody>
-          <a:bodyPr rtlCol="0" anchor="ctr"/>
-          <a:lstStyle/>
-          <a:p>
-            <a:pPr algn="ctr"/>
-          </a:p>
-        </p:txBody>
-      </p:sp>
-      <p:sp>
-        <p:nvSpPr>
-          <p:cNvPr id="50" name="TextBox 49"/>
-          <p:cNvSpPr txBox="1"/>
-          <p:nvPr/>
-        </p:nvSpPr>
-        <p:spPr>
-          <a:xfrm>
-            <a:off x="10415016" y="1444752"/>
-            <a:ext cx="1536192" cy="530352"/>
-          </a:xfrm>
-          <a:prstGeom prst="rect">
-            <a:avLst/>
-          </a:prstGeom>
-          <a:noFill/>
-        </p:spPr>
-        <p:txBody>
-          <a:bodyPr wrap="square">
-            <a:spAutoFit/>
-          </a:bodyPr>
-          <a:lstStyle/>
-          <a:p>
-            <a:pPr algn="ctr"/>
-            <a:r>
-              <a:rPr sz="900" b="1" i="0">
-                <a:solidFill>
-                  <a:srgbClr val="FFFFFF"/>
-                </a:solidFill>
-              </a:rPr>
-              <a:t>08:30
-–10:00</a:t>
-            </a:r>
-          </a:p>
-        </p:txBody>
-      </p:sp>
-      <p:sp>
-        <p:nvSpPr>
-          <p:cNvPr id="51" name="Rectangle 50"/>
-          <p:cNvSpPr/>
-          <p:nvPr/>
-        </p:nvSpPr>
-        <p:spPr>
-          <a:xfrm>
-            <a:off x="10415016" y="1975104"/>
-            <a:ext cx="1536192" cy="502920"/>
-          </a:xfrm>
-          <a:prstGeom prst="rect">
-            <a:avLst/>
-          </a:prstGeom>
-          <a:solidFill>
-            <a:srgbClr val="F05A28"/>
-          </a:solidFill>
-          <a:ln>
-            <a:noFill/>
-          </a:ln>
-        </p:spPr>
-        <p:style>
-          <a:lnRef idx="1">
-            <a:schemeClr val="accent1"/>
-          </a:lnRef>
-          <a:fillRef idx="3">
-            <a:schemeClr val="accent1"/>
-          </a:fillRef>
-          <a:effectRef idx="2">
-            <a:schemeClr val="accent1"/>
-          </a:effectRef>
-          <a:fontRef idx="minor">
-            <a:schemeClr val="lt1"/>
-          </a:fontRef>
-        </p:style>
-        <p:txBody>
-          <a:bodyPr rtlCol="0" anchor="ctr"/>
-          <a:lstStyle/>
-          <a:p>
-            <a:pPr algn="ctr"/>
-          </a:p>
-        </p:txBody>
-      </p:sp>
-      <p:sp>
-        <p:nvSpPr>
-          <p:cNvPr id="52" name="TextBox 51"/>
-          <p:cNvSpPr txBox="1"/>
-          <p:nvPr/>
-        </p:nvSpPr>
-        <p:spPr>
-          <a:xfrm>
-            <a:off x="10415016" y="1975104"/>
-            <a:ext cx="1536192" cy="502920"/>
-          </a:xfrm>
-          <a:prstGeom prst="rect">
-            <a:avLst/>
-          </a:prstGeom>
-          <a:noFill/>
-        </p:spPr>
-        <p:txBody>
-          <a:bodyPr wrap="square">
-            <a:spAutoFit/>
-          </a:bodyPr>
-          <a:lstStyle/>
-          <a:p>
-            <a:pPr algn="ctr"/>
-            <a:r>
-              <a:rPr sz="1000" b="1" i="0">
-                <a:solidFill>
-                  <a:srgbClr val="FFFFFF"/>
-                </a:solidFill>
-              </a:rPr>
-              <a:t>Q&amp;A</a:t>
-            </a:r>
-          </a:p>
-        </p:txBody>
-      </p:sp>
-      <p:sp>
-        <p:nvSpPr>
-          <p:cNvPr id="53" name="Rectangle 52"/>
-          <p:cNvSpPr/>
-          <p:nvPr/>
-        </p:nvSpPr>
-        <p:spPr>
-          <a:xfrm>
-            <a:off x="10415016" y="2478024"/>
-            <a:ext cx="1536192" cy="4069080"/>
-          </a:xfrm>
-          <a:prstGeom prst="rect">
-            <a:avLst/>
-          </a:prstGeom>
-          <a:solidFill>
-            <a:srgbClr val="EEF2F8"/>
-          </a:solidFill>
-          <a:ln w="12700">
-            <a:solidFill>
-              <a:srgbClr val="0A7A4A"/>
-            </a:solidFill>
-          </a:ln>
-        </p:spPr>
-        <p:style>
-          <a:lnRef idx="1">
-            <a:schemeClr val="accent1"/>
-          </a:lnRef>
-          <a:fillRef idx="3">
-            <a:schemeClr val="accent1"/>
-          </a:fillRef>
-          <a:effectRef idx="2">
-            <a:schemeClr val="accent1"/>
-          </a:effectRef>
-          <a:fontRef idx="minor">
-            <a:schemeClr val="lt1"/>
-          </a:fontRef>
-        </p:style>
-        <p:txBody>
-          <a:bodyPr rtlCol="0" anchor="ctr"/>
-          <a:lstStyle/>
-          <a:p>
-            <a:pPr algn="ctr"/>
-          </a:p>
-        </p:txBody>
-      </p:sp>
-      <p:sp>
-        <p:nvSpPr>
-          <p:cNvPr id="54" name="TextBox 53"/>
-          <p:cNvSpPr txBox="1"/>
-          <p:nvPr/>
-        </p:nvSpPr>
-        <p:spPr>
-          <a:xfrm>
-            <a:off x="10488168" y="2578608"/>
-            <a:ext cx="1389888" cy="3840480"/>
-          </a:xfrm>
-          <a:prstGeom prst="rect">
-            <a:avLst/>
-          </a:prstGeom>
-          <a:noFill/>
-        </p:spPr>
-        <p:txBody>
-          <a:bodyPr wrap="square">
-            <a:spAutoFit/>
-          </a:bodyPr>
-          <a:lstStyle/>
-          <a:p>
-            <a:pPr algn="l"/>
-            <a:r>
-              <a:rPr sz="950" b="0" i="0">
-                <a:solidFill>
-                  <a:srgbClr val="1A2038"/>
-                </a:solidFill>
-              </a:rPr>
-              <a:t>Panel questions.
-Key differentiators:
-RRF · 4-dim risk · A2A · Graceful fallbacks.</a:t>
+            <a:off x="8321040" y="5193792"/>
+            <a:ext cx="3474720" cy="640080"/>
+          </a:xfrm>
+          <a:prstGeom prst="rect">
+            <a:avLst/>
+          </a:prstGeom>
+          <a:noFill/>
+        </p:spPr>
+        <p:txBody>
+          <a:bodyPr wrap="square">
+            <a:spAutoFit/>
+          </a:bodyPr>
+          <a:lstStyle/>
+          <a:p>
+            <a:pPr algn="ctr"/>
+            <a:r>
+              <a:rPr sz="1000" b="0" i="0">
+                <a:solidFill>
+                  <a:srgbClr val="6B7A9A"/>
+                </a:solidFill>
+              </a:rPr>
+              <a:t>Parallel + A2A escalation in ~22s</a:t>
             </a:r>
           </a:p>
         </p:txBody>
@@ -8833,1369 +8116,6 @@
 </file>
 
 <file path=ppt/slides/slide13.xml><?xml version="1.0" encoding="utf-8"?>
-<p:sld xmlns:a="http://schemas.openxmlformats.org/drawingml/2006/main" xmlns:p="http://schemas.openxmlformats.org/presentationml/2006/main" xmlns:r="http://schemas.openxmlformats.org/officeDocument/2006/relationships">
-  <p:cSld>
-    <p:bg>
-      <p:bgPr>
-        <a:solidFill>
-          <a:srgbClr val="F4F6FB"/>
-        </a:solidFill>
-        <a:effectLst/>
-      </p:bgPr>
-    </p:bg>
-    <p:spTree>
-      <p:nvGrpSpPr>
-        <p:cNvPr id="1" name=""/>
-        <p:cNvGrpSpPr/>
-        <p:nvPr/>
-      </p:nvGrpSpPr>
-      <p:grpSpPr/>
-      <p:sp>
-        <p:nvSpPr>
-          <p:cNvPr id="2" name="Rectangle 1"/>
-          <p:cNvSpPr/>
-          <p:nvPr/>
-        </p:nvSpPr>
-        <p:spPr>
-          <a:xfrm>
-            <a:off x="0" y="0"/>
-            <a:ext cx="12188952" cy="64008"/>
-          </a:xfrm>
-          <a:prstGeom prst="rect">
-            <a:avLst/>
-          </a:prstGeom>
-          <a:solidFill>
-            <a:srgbClr val="F05A28"/>
-          </a:solidFill>
-          <a:ln>
-            <a:noFill/>
-          </a:ln>
-        </p:spPr>
-        <p:style>
-          <a:lnRef idx="1">
-            <a:schemeClr val="accent1"/>
-          </a:lnRef>
-          <a:fillRef idx="3">
-            <a:schemeClr val="accent1"/>
-          </a:fillRef>
-          <a:effectRef idx="2">
-            <a:schemeClr val="accent1"/>
-          </a:effectRef>
-          <a:fontRef idx="minor">
-            <a:schemeClr val="lt1"/>
-          </a:fontRef>
-        </p:style>
-        <p:txBody>
-          <a:bodyPr rtlCol="0" anchor="ctr"/>
-          <a:lstStyle/>
-          <a:p>
-            <a:pPr algn="ctr"/>
-          </a:p>
-        </p:txBody>
-      </p:sp>
-      <p:sp>
-        <p:nvSpPr>
-          <p:cNvPr id="3" name="Rectangle 2"/>
-          <p:cNvSpPr/>
-          <p:nvPr/>
-        </p:nvSpPr>
-        <p:spPr>
-          <a:xfrm>
-            <a:off x="0" y="64008"/>
-            <a:ext cx="12188952" cy="987552"/>
-          </a:xfrm>
-          <a:prstGeom prst="rect">
-            <a:avLst/>
-          </a:prstGeom>
-          <a:solidFill>
-            <a:srgbClr val="1C3461"/>
-          </a:solidFill>
-          <a:ln>
-            <a:noFill/>
-          </a:ln>
-        </p:spPr>
-        <p:style>
-          <a:lnRef idx="1">
-            <a:schemeClr val="accent1"/>
-          </a:lnRef>
-          <a:fillRef idx="3">
-            <a:schemeClr val="accent1"/>
-          </a:fillRef>
-          <a:effectRef idx="2">
-            <a:schemeClr val="accent1"/>
-          </a:effectRef>
-          <a:fontRef idx="minor">
-            <a:schemeClr val="lt1"/>
-          </a:fontRef>
-        </p:style>
-        <p:txBody>
-          <a:bodyPr rtlCol="0" anchor="ctr"/>
-          <a:lstStyle/>
-          <a:p>
-            <a:pPr algn="ctr"/>
-          </a:p>
-        </p:txBody>
-      </p:sp>
-      <p:sp>
-        <p:nvSpPr>
-          <p:cNvPr id="4" name="TextBox 3"/>
-          <p:cNvSpPr txBox="1"/>
-          <p:nvPr/>
-        </p:nvSpPr>
-        <p:spPr>
-          <a:xfrm>
-            <a:off x="457200" y="109728"/>
-            <a:ext cx="10972800" cy="640080"/>
-          </a:xfrm>
-          <a:prstGeom prst="rect">
-            <a:avLst/>
-          </a:prstGeom>
-          <a:noFill/>
-        </p:spPr>
-        <p:txBody>
-          <a:bodyPr wrap="square">
-            <a:spAutoFit/>
-          </a:bodyPr>
-          <a:lstStyle/>
-          <a:p>
-            <a:pPr algn="l"/>
-            <a:r>
-              <a:rPr sz="2200" b="1" i="0">
-                <a:solidFill>
-                  <a:srgbClr val="FFFFFF"/>
-                </a:solidFill>
-              </a:rPr>
-              <a:t>Performance &amp; Results</a:t>
-            </a:r>
-          </a:p>
-        </p:txBody>
-      </p:sp>
-      <p:sp>
-        <p:nvSpPr>
-          <p:cNvPr id="5" name="TextBox 4"/>
-          <p:cNvSpPr txBox="1"/>
-          <p:nvPr/>
-        </p:nvSpPr>
-        <p:spPr>
-          <a:xfrm>
-            <a:off x="457200" y="731520"/>
-            <a:ext cx="10972800" cy="329184"/>
-          </a:xfrm>
-          <a:prstGeom prst="rect">
-            <a:avLst/>
-          </a:prstGeom>
-          <a:noFill/>
-        </p:spPr>
-        <p:txBody>
-          <a:bodyPr wrap="square">
-            <a:spAutoFit/>
-          </a:bodyPr>
-          <a:lstStyle/>
-          <a:p>
-            <a:pPr algn="l"/>
-            <a:r>
-              <a:rPr sz="1200" b="0" i="0">
-                <a:solidFill>
-                  <a:srgbClr val="C8D3E8"/>
-                </a:solidFill>
-              </a:rPr>
-              <a:t>Live test results on 600-incident corpus with local sentence-transformer embeddings</a:t>
-            </a:r>
-          </a:p>
-        </p:txBody>
-      </p:sp>
-      <p:sp>
-        <p:nvSpPr>
-          <p:cNvPr id="6" name="Rectangle 5"/>
-          <p:cNvSpPr/>
-          <p:nvPr/>
-        </p:nvSpPr>
-        <p:spPr>
-          <a:xfrm>
-            <a:off x="0" y="6583680"/>
-            <a:ext cx="12188952" cy="54864"/>
-          </a:xfrm>
-          <a:prstGeom prst="rect">
-            <a:avLst/>
-          </a:prstGeom>
-          <a:solidFill>
-            <a:srgbClr val="F05A28"/>
-          </a:solidFill>
-          <a:ln>
-            <a:noFill/>
-          </a:ln>
-        </p:spPr>
-        <p:style>
-          <a:lnRef idx="1">
-            <a:schemeClr val="accent1"/>
-          </a:lnRef>
-          <a:fillRef idx="3">
-            <a:schemeClr val="accent1"/>
-          </a:fillRef>
-          <a:effectRef idx="2">
-            <a:schemeClr val="accent1"/>
-          </a:effectRef>
-          <a:fontRef idx="minor">
-            <a:schemeClr val="lt1"/>
-          </a:fontRef>
-        </p:style>
-        <p:txBody>
-          <a:bodyPr rtlCol="0" anchor="ctr"/>
-          <a:lstStyle/>
-          <a:p>
-            <a:pPr algn="ctr"/>
-          </a:p>
-        </p:txBody>
-      </p:sp>
-      <p:sp>
-        <p:nvSpPr>
-          <p:cNvPr id="7" name="Rectangle 6"/>
-          <p:cNvSpPr/>
-          <p:nvPr/>
-        </p:nvSpPr>
-        <p:spPr>
-          <a:xfrm>
-            <a:off x="365760" y="1444752"/>
-            <a:ext cx="3657600" cy="54864"/>
-          </a:xfrm>
-          <a:prstGeom prst="rect">
-            <a:avLst/>
-          </a:prstGeom>
-          <a:solidFill>
-            <a:srgbClr val="1C3461"/>
-          </a:solidFill>
-          <a:ln>
-            <a:noFill/>
-          </a:ln>
-        </p:spPr>
-        <p:style>
-          <a:lnRef idx="1">
-            <a:schemeClr val="accent1"/>
-          </a:lnRef>
-          <a:fillRef idx="3">
-            <a:schemeClr val="accent1"/>
-          </a:fillRef>
-          <a:effectRef idx="2">
-            <a:schemeClr val="accent1"/>
-          </a:effectRef>
-          <a:fontRef idx="minor">
-            <a:schemeClr val="lt1"/>
-          </a:fontRef>
-        </p:style>
-        <p:txBody>
-          <a:bodyPr rtlCol="0" anchor="ctr"/>
-          <a:lstStyle/>
-          <a:p>
-            <a:pPr algn="ctr"/>
-          </a:p>
-        </p:txBody>
-      </p:sp>
-      <p:sp>
-        <p:nvSpPr>
-          <p:cNvPr id="8" name="Rectangle 7"/>
-          <p:cNvSpPr/>
-          <p:nvPr/>
-        </p:nvSpPr>
-        <p:spPr>
-          <a:xfrm>
-            <a:off x="365760" y="1499616"/>
-            <a:ext cx="3657600" cy="2057400"/>
-          </a:xfrm>
-          <a:prstGeom prst="rect">
-            <a:avLst/>
-          </a:prstGeom>
-          <a:solidFill>
-            <a:srgbClr val="EEF2F8"/>
-          </a:solidFill>
-          <a:ln w="10160">
-            <a:solidFill>
-              <a:srgbClr val="1C3461"/>
-            </a:solidFill>
-          </a:ln>
-        </p:spPr>
-        <p:style>
-          <a:lnRef idx="1">
-            <a:schemeClr val="accent1"/>
-          </a:lnRef>
-          <a:fillRef idx="3">
-            <a:schemeClr val="accent1"/>
-          </a:fillRef>
-          <a:effectRef idx="2">
-            <a:schemeClr val="accent1"/>
-          </a:effectRef>
-          <a:fontRef idx="minor">
-            <a:schemeClr val="lt1"/>
-          </a:fontRef>
-        </p:style>
-        <p:txBody>
-          <a:bodyPr rtlCol="0" anchor="ctr"/>
-          <a:lstStyle/>
-          <a:p>
-            <a:pPr algn="ctr"/>
-          </a:p>
-        </p:txBody>
-      </p:sp>
-      <p:sp>
-        <p:nvSpPr>
-          <p:cNvPr id="9" name="TextBox 8"/>
-          <p:cNvSpPr txBox="1"/>
-          <p:nvPr/>
-        </p:nvSpPr>
-        <p:spPr>
-          <a:xfrm>
-            <a:off x="365760" y="1609344"/>
-            <a:ext cx="3657600" cy="822960"/>
-          </a:xfrm>
-          <a:prstGeom prst="rect">
-            <a:avLst/>
-          </a:prstGeom>
-          <a:noFill/>
-        </p:spPr>
-        <p:txBody>
-          <a:bodyPr wrap="square">
-            <a:spAutoFit/>
-          </a:bodyPr>
-          <a:lstStyle/>
-          <a:p>
-            <a:pPr algn="ctr"/>
-            <a:r>
-              <a:rPr sz="3200" b="1" i="0">
-                <a:solidFill>
-                  <a:srgbClr val="1C3461"/>
-                </a:solidFill>
-              </a:rPr>
-              <a:t>40 ms</a:t>
-            </a:r>
-          </a:p>
-        </p:txBody>
-      </p:sp>
-      <p:sp>
-        <p:nvSpPr>
-          <p:cNvPr id="10" name="TextBox 9"/>
-          <p:cNvSpPr txBox="1"/>
-          <p:nvPr/>
-        </p:nvSpPr>
-        <p:spPr>
-          <a:xfrm>
-            <a:off x="365760" y="2450592"/>
-            <a:ext cx="3657600" cy="365760"/>
-          </a:xfrm>
-          <a:prstGeom prst="rect">
-            <a:avLst/>
-          </a:prstGeom>
-          <a:noFill/>
-        </p:spPr>
-        <p:txBody>
-          <a:bodyPr wrap="square">
-            <a:spAutoFit/>
-          </a:bodyPr>
-          <a:lstStyle/>
-          <a:p>
-            <a:pPr algn="ctr"/>
-            <a:r>
-              <a:rPr sz="1300" b="1" i="0">
-                <a:solidFill>
-                  <a:srgbClr val="1C3461"/>
-                </a:solidFill>
-              </a:rPr>
-              <a:t>Search Latency</a:t>
-            </a:r>
-          </a:p>
-        </p:txBody>
-      </p:sp>
-      <p:sp>
-        <p:nvSpPr>
-          <p:cNvPr id="11" name="TextBox 10"/>
-          <p:cNvSpPr txBox="1"/>
-          <p:nvPr/>
-        </p:nvSpPr>
-        <p:spPr>
-          <a:xfrm>
-            <a:off x="457200" y="2862072"/>
-            <a:ext cx="3474720" cy="640080"/>
-          </a:xfrm>
-          <a:prstGeom prst="rect">
-            <a:avLst/>
-          </a:prstGeom>
-          <a:noFill/>
-        </p:spPr>
-        <p:txBody>
-          <a:bodyPr wrap="square">
-            <a:spAutoFit/>
-          </a:bodyPr>
-          <a:lstStyle/>
-          <a:p>
-            <a:pPr algn="ctr"/>
-            <a:r>
-              <a:rPr sz="1000" b="0" i="0">
-                <a:solidFill>
-                  <a:srgbClr val="6B7A9A"/>
-                </a:solidFill>
-              </a:rPr>
-              <a:t>Hybrid BM25+Semantic (local embeddings)</a:t>
-            </a:r>
-          </a:p>
-        </p:txBody>
-      </p:sp>
-      <p:sp>
-        <p:nvSpPr>
-          <p:cNvPr id="12" name="Rectangle 11"/>
-          <p:cNvSpPr/>
-          <p:nvPr/>
-        </p:nvSpPr>
-        <p:spPr>
-          <a:xfrm>
-            <a:off x="4297680" y="1444752"/>
-            <a:ext cx="3657600" cy="54864"/>
-          </a:xfrm>
-          <a:prstGeom prst="rect">
-            <a:avLst/>
-          </a:prstGeom>
-          <a:solidFill>
-            <a:srgbClr val="243D72"/>
-          </a:solidFill>
-          <a:ln>
-            <a:noFill/>
-          </a:ln>
-        </p:spPr>
-        <p:style>
-          <a:lnRef idx="1">
-            <a:schemeClr val="accent1"/>
-          </a:lnRef>
-          <a:fillRef idx="3">
-            <a:schemeClr val="accent1"/>
-          </a:fillRef>
-          <a:effectRef idx="2">
-            <a:schemeClr val="accent1"/>
-          </a:effectRef>
-          <a:fontRef idx="minor">
-            <a:schemeClr val="lt1"/>
-          </a:fontRef>
-        </p:style>
-        <p:txBody>
-          <a:bodyPr rtlCol="0" anchor="ctr"/>
-          <a:lstStyle/>
-          <a:p>
-            <a:pPr algn="ctr"/>
-          </a:p>
-        </p:txBody>
-      </p:sp>
-      <p:sp>
-        <p:nvSpPr>
-          <p:cNvPr id="13" name="Rectangle 12"/>
-          <p:cNvSpPr/>
-          <p:nvPr/>
-        </p:nvSpPr>
-        <p:spPr>
-          <a:xfrm>
-            <a:off x="4297680" y="1499616"/>
-            <a:ext cx="3657600" cy="2057400"/>
-          </a:xfrm>
-          <a:prstGeom prst="rect">
-            <a:avLst/>
-          </a:prstGeom>
-          <a:solidFill>
-            <a:srgbClr val="EEF2F8"/>
-          </a:solidFill>
-          <a:ln w="10160">
-            <a:solidFill>
-              <a:srgbClr val="1C3461"/>
-            </a:solidFill>
-          </a:ln>
-        </p:spPr>
-        <p:style>
-          <a:lnRef idx="1">
-            <a:schemeClr val="accent1"/>
-          </a:lnRef>
-          <a:fillRef idx="3">
-            <a:schemeClr val="accent1"/>
-          </a:fillRef>
-          <a:effectRef idx="2">
-            <a:schemeClr val="accent1"/>
-          </a:effectRef>
-          <a:fontRef idx="minor">
-            <a:schemeClr val="lt1"/>
-          </a:fontRef>
-        </p:style>
-        <p:txBody>
-          <a:bodyPr rtlCol="0" anchor="ctr"/>
-          <a:lstStyle/>
-          <a:p>
-            <a:pPr algn="ctr"/>
-          </a:p>
-        </p:txBody>
-      </p:sp>
-      <p:sp>
-        <p:nvSpPr>
-          <p:cNvPr id="14" name="TextBox 13"/>
-          <p:cNvSpPr txBox="1"/>
-          <p:nvPr/>
-        </p:nvSpPr>
-        <p:spPr>
-          <a:xfrm>
-            <a:off x="4297680" y="1609344"/>
-            <a:ext cx="3657600" cy="822960"/>
-          </a:xfrm>
-          <a:prstGeom prst="rect">
-            <a:avLst/>
-          </a:prstGeom>
-          <a:noFill/>
-        </p:spPr>
-        <p:txBody>
-          <a:bodyPr wrap="square">
-            <a:spAutoFit/>
-          </a:bodyPr>
-          <a:lstStyle/>
-          <a:p>
-            <a:pPr algn="ctr"/>
-            <a:r>
-              <a:rPr sz="3200" b="1" i="0">
-                <a:solidFill>
-                  <a:srgbClr val="243D72"/>
-                </a:solidFill>
-              </a:rPr>
-              <a:t>600</a:t>
-            </a:r>
-          </a:p>
-        </p:txBody>
-      </p:sp>
-      <p:sp>
-        <p:nvSpPr>
-          <p:cNvPr id="15" name="TextBox 14"/>
-          <p:cNvSpPr txBox="1"/>
-          <p:nvPr/>
-        </p:nvSpPr>
-        <p:spPr>
-          <a:xfrm>
-            <a:off x="4297680" y="2450592"/>
-            <a:ext cx="3657600" cy="365760"/>
-          </a:xfrm>
-          <a:prstGeom prst="rect">
-            <a:avLst/>
-          </a:prstGeom>
-          <a:noFill/>
-        </p:spPr>
-        <p:txBody>
-          <a:bodyPr wrap="square">
-            <a:spAutoFit/>
-          </a:bodyPr>
-          <a:lstStyle/>
-          <a:p>
-            <a:pPr algn="ctr"/>
-            <a:r>
-              <a:rPr sz="1300" b="1" i="0">
-                <a:solidFill>
-                  <a:srgbClr val="1C3461"/>
-                </a:solidFill>
-              </a:rPr>
-              <a:t>Indexed Incidents</a:t>
-            </a:r>
-          </a:p>
-        </p:txBody>
-      </p:sp>
-      <p:sp>
-        <p:nvSpPr>
-          <p:cNvPr id="16" name="TextBox 15"/>
-          <p:cNvSpPr txBox="1"/>
-          <p:nvPr/>
-        </p:nvSpPr>
-        <p:spPr>
-          <a:xfrm>
-            <a:off x="4389120" y="2862072"/>
-            <a:ext cx="3474720" cy="640080"/>
-          </a:xfrm>
-          <a:prstGeom prst="rect">
-            <a:avLst/>
-          </a:prstGeom>
-          <a:noFill/>
-        </p:spPr>
-        <p:txBody>
-          <a:bodyPr wrap="square">
-            <a:spAutoFit/>
-          </a:bodyPr>
-          <a:lstStyle/>
-          <a:p>
-            <a:pPr algn="ctr"/>
-            <a:r>
-              <a:rPr sz="1000" b="0" i="0">
-                <a:solidFill>
-                  <a:srgbClr val="6B7A9A"/>
-                </a:solidFill>
-              </a:rPr>
-              <a:t>2024–2026 synthetic supply chain records</a:t>
-            </a:r>
-          </a:p>
-        </p:txBody>
-      </p:sp>
-      <p:sp>
-        <p:nvSpPr>
-          <p:cNvPr id="17" name="Rectangle 16"/>
-          <p:cNvSpPr/>
-          <p:nvPr/>
-        </p:nvSpPr>
-        <p:spPr>
-          <a:xfrm>
-            <a:off x="8229600" y="1444752"/>
-            <a:ext cx="3657600" cy="54864"/>
-          </a:xfrm>
-          <a:prstGeom prst="rect">
-            <a:avLst/>
-          </a:prstGeom>
-          <a:solidFill>
-            <a:srgbClr val="F05A28"/>
-          </a:solidFill>
-          <a:ln>
-            <a:noFill/>
-          </a:ln>
-        </p:spPr>
-        <p:style>
-          <a:lnRef idx="1">
-            <a:schemeClr val="accent1"/>
-          </a:lnRef>
-          <a:fillRef idx="3">
-            <a:schemeClr val="accent1"/>
-          </a:fillRef>
-          <a:effectRef idx="2">
-            <a:schemeClr val="accent1"/>
-          </a:effectRef>
-          <a:fontRef idx="minor">
-            <a:schemeClr val="lt1"/>
-          </a:fontRef>
-        </p:style>
-        <p:txBody>
-          <a:bodyPr rtlCol="0" anchor="ctr"/>
-          <a:lstStyle/>
-          <a:p>
-            <a:pPr algn="ctr"/>
-          </a:p>
-        </p:txBody>
-      </p:sp>
-      <p:sp>
-        <p:nvSpPr>
-          <p:cNvPr id="18" name="Rectangle 17"/>
-          <p:cNvSpPr/>
-          <p:nvPr/>
-        </p:nvSpPr>
-        <p:spPr>
-          <a:xfrm>
-            <a:off x="8229600" y="1499616"/>
-            <a:ext cx="3657600" cy="2057400"/>
-          </a:xfrm>
-          <a:prstGeom prst="rect">
-            <a:avLst/>
-          </a:prstGeom>
-          <a:solidFill>
-            <a:srgbClr val="EEF2F8"/>
-          </a:solidFill>
-          <a:ln w="10160">
-            <a:solidFill>
-              <a:srgbClr val="1C3461"/>
-            </a:solidFill>
-          </a:ln>
-        </p:spPr>
-        <p:style>
-          <a:lnRef idx="1">
-            <a:schemeClr val="accent1"/>
-          </a:lnRef>
-          <a:fillRef idx="3">
-            <a:schemeClr val="accent1"/>
-          </a:fillRef>
-          <a:effectRef idx="2">
-            <a:schemeClr val="accent1"/>
-          </a:effectRef>
-          <a:fontRef idx="minor">
-            <a:schemeClr val="lt1"/>
-          </a:fontRef>
-        </p:style>
-        <p:txBody>
-          <a:bodyPr rtlCol="0" anchor="ctr"/>
-          <a:lstStyle/>
-          <a:p>
-            <a:pPr algn="ctr"/>
-          </a:p>
-        </p:txBody>
-      </p:sp>
-      <p:sp>
-        <p:nvSpPr>
-          <p:cNvPr id="19" name="TextBox 18"/>
-          <p:cNvSpPr txBox="1"/>
-          <p:nvPr/>
-        </p:nvSpPr>
-        <p:spPr>
-          <a:xfrm>
-            <a:off x="8229600" y="1609344"/>
-            <a:ext cx="3657600" cy="822960"/>
-          </a:xfrm>
-          <a:prstGeom prst="rect">
-            <a:avLst/>
-          </a:prstGeom>
-          <a:noFill/>
-        </p:spPr>
-        <p:txBody>
-          <a:bodyPr wrap="square">
-            <a:spAutoFit/>
-          </a:bodyPr>
-          <a:lstStyle/>
-          <a:p>
-            <a:pPr algn="ctr"/>
-            <a:r>
-              <a:rPr sz="3200" b="1" i="0">
-                <a:solidFill>
-                  <a:srgbClr val="F05A28"/>
-                </a:solidFill>
-              </a:rPr>
-              <a:t>30</a:t>
-            </a:r>
-          </a:p>
-        </p:txBody>
-      </p:sp>
-      <p:sp>
-        <p:nvSpPr>
-          <p:cNvPr id="20" name="TextBox 19"/>
-          <p:cNvSpPr txBox="1"/>
-          <p:nvPr/>
-        </p:nvSpPr>
-        <p:spPr>
-          <a:xfrm>
-            <a:off x="8229600" y="2450592"/>
-            <a:ext cx="3657600" cy="365760"/>
-          </a:xfrm>
-          <a:prstGeom prst="rect">
-            <a:avLst/>
-          </a:prstGeom>
-          <a:noFill/>
-        </p:spPr>
-        <p:txBody>
-          <a:bodyPr wrap="square">
-            <a:spAutoFit/>
-          </a:bodyPr>
-          <a:lstStyle/>
-          <a:p>
-            <a:pPr algn="ctr"/>
-            <a:r>
-              <a:rPr sz="1300" b="1" i="0">
-                <a:solidFill>
-                  <a:srgbClr val="1C3461"/>
-                </a:solidFill>
-              </a:rPr>
-              <a:t>Anomalies Found</a:t>
-            </a:r>
-          </a:p>
-        </p:txBody>
-      </p:sp>
-      <p:sp>
-        <p:nvSpPr>
-          <p:cNvPr id="21" name="TextBox 20"/>
-          <p:cNvSpPr txBox="1"/>
-          <p:nvPr/>
-        </p:nvSpPr>
-        <p:spPr>
-          <a:xfrm>
-            <a:off x="8321040" y="2862072"/>
-            <a:ext cx="3474720" cy="640080"/>
-          </a:xfrm>
-          <a:prstGeom prst="rect">
-            <a:avLst/>
-          </a:prstGeom>
-          <a:noFill/>
-        </p:spPr>
-        <p:txBody>
-          <a:bodyPr wrap="square">
-            <a:spAutoFit/>
-          </a:bodyPr>
-          <a:lstStyle/>
-          <a:p>
-            <a:pPr algn="ctr"/>
-            <a:r>
-              <a:rPr sz="1000" b="0" i="0">
-                <a:solidFill>
-                  <a:srgbClr val="6B7A9A"/>
-                </a:solidFill>
-              </a:rPr>
-              <a:t>IsolationForest contamination=0.05</a:t>
-            </a:r>
-          </a:p>
-        </p:txBody>
-      </p:sp>
-      <p:sp>
-        <p:nvSpPr>
-          <p:cNvPr id="22" name="Rectangle 21"/>
-          <p:cNvSpPr/>
-          <p:nvPr/>
-        </p:nvSpPr>
-        <p:spPr>
-          <a:xfrm>
-            <a:off x="365760" y="3776472"/>
-            <a:ext cx="3657600" cy="54864"/>
-          </a:xfrm>
-          <a:prstGeom prst="rect">
-            <a:avLst/>
-          </a:prstGeom>
-          <a:solidFill>
-            <a:srgbClr val="C47A00"/>
-          </a:solidFill>
-          <a:ln>
-            <a:noFill/>
-          </a:ln>
-        </p:spPr>
-        <p:style>
-          <a:lnRef idx="1">
-            <a:schemeClr val="accent1"/>
-          </a:lnRef>
-          <a:fillRef idx="3">
-            <a:schemeClr val="accent1"/>
-          </a:fillRef>
-          <a:effectRef idx="2">
-            <a:schemeClr val="accent1"/>
-          </a:effectRef>
-          <a:fontRef idx="minor">
-            <a:schemeClr val="lt1"/>
-          </a:fontRef>
-        </p:style>
-        <p:txBody>
-          <a:bodyPr rtlCol="0" anchor="ctr"/>
-          <a:lstStyle/>
-          <a:p>
-            <a:pPr algn="ctr"/>
-          </a:p>
-        </p:txBody>
-      </p:sp>
-      <p:sp>
-        <p:nvSpPr>
-          <p:cNvPr id="23" name="Rectangle 22"/>
-          <p:cNvSpPr/>
-          <p:nvPr/>
-        </p:nvSpPr>
-        <p:spPr>
-          <a:xfrm>
-            <a:off x="365760" y="3831336"/>
-            <a:ext cx="3657600" cy="2057400"/>
-          </a:xfrm>
-          <a:prstGeom prst="rect">
-            <a:avLst/>
-          </a:prstGeom>
-          <a:solidFill>
-            <a:srgbClr val="EEF2F8"/>
-          </a:solidFill>
-          <a:ln w="10160">
-            <a:solidFill>
-              <a:srgbClr val="1C3461"/>
-            </a:solidFill>
-          </a:ln>
-        </p:spPr>
-        <p:style>
-          <a:lnRef idx="1">
-            <a:schemeClr val="accent1"/>
-          </a:lnRef>
-          <a:fillRef idx="3">
-            <a:schemeClr val="accent1"/>
-          </a:fillRef>
-          <a:effectRef idx="2">
-            <a:schemeClr val="accent1"/>
-          </a:effectRef>
-          <a:fontRef idx="minor">
-            <a:schemeClr val="lt1"/>
-          </a:fontRef>
-        </p:style>
-        <p:txBody>
-          <a:bodyPr rtlCol="0" anchor="ctr"/>
-          <a:lstStyle/>
-          <a:p>
-            <a:pPr algn="ctr"/>
-          </a:p>
-        </p:txBody>
-      </p:sp>
-      <p:sp>
-        <p:nvSpPr>
-          <p:cNvPr id="24" name="TextBox 23"/>
-          <p:cNvSpPr txBox="1"/>
-          <p:nvPr/>
-        </p:nvSpPr>
-        <p:spPr>
-          <a:xfrm>
-            <a:off x="365760" y="3941064"/>
-            <a:ext cx="3657600" cy="822960"/>
-          </a:xfrm>
-          <a:prstGeom prst="rect">
-            <a:avLst/>
-          </a:prstGeom>
-          <a:noFill/>
-        </p:spPr>
-        <p:txBody>
-          <a:bodyPr wrap="square">
-            <a:spAutoFit/>
-          </a:bodyPr>
-          <a:lstStyle/>
-          <a:p>
-            <a:pPr algn="ctr"/>
-            <a:r>
-              <a:rPr sz="3200" b="1" i="0">
-                <a:solidFill>
-                  <a:srgbClr val="C47A00"/>
-                </a:solidFill>
-              </a:rPr>
-              <a:t>9.19d</a:t>
-            </a:r>
-          </a:p>
-        </p:txBody>
-      </p:sp>
-      <p:sp>
-        <p:nvSpPr>
-          <p:cNvPr id="25" name="TextBox 24"/>
-          <p:cNvSpPr txBox="1"/>
-          <p:nvPr/>
-        </p:nvSpPr>
-        <p:spPr>
-          <a:xfrm>
-            <a:off x="365760" y="4782312"/>
-            <a:ext cx="3657600" cy="365760"/>
-          </a:xfrm>
-          <a:prstGeom prst="rect">
-            <a:avLst/>
-          </a:prstGeom>
-          <a:noFill/>
-        </p:spPr>
-        <p:txBody>
-          <a:bodyPr wrap="square">
-            <a:spAutoFit/>
-          </a:bodyPr>
-          <a:lstStyle/>
-          <a:p>
-            <a:pPr algn="ctr"/>
-            <a:r>
-              <a:rPr sz="1300" b="1" i="0">
-                <a:solidFill>
-                  <a:srgbClr val="1C3461"/>
-                </a:solidFill>
-              </a:rPr>
-              <a:t>Avg Delivery Delay</a:t>
-            </a:r>
-          </a:p>
-        </p:txBody>
-      </p:sp>
-      <p:sp>
-        <p:nvSpPr>
-          <p:cNvPr id="26" name="TextBox 25"/>
-          <p:cNvSpPr txBox="1"/>
-          <p:nvPr/>
-        </p:nvSpPr>
-        <p:spPr>
-          <a:xfrm>
-            <a:off x="457200" y="5193792"/>
-            <a:ext cx="3474720" cy="640080"/>
-          </a:xfrm>
-          <a:prstGeom prst="rect">
-            <a:avLst/>
-          </a:prstGeom>
-          <a:noFill/>
-        </p:spPr>
-        <p:txBody>
-          <a:bodyPr wrap="square">
-            <a:spAutoFit/>
-          </a:bodyPr>
-          <a:lstStyle/>
-          <a:p>
-            <a:pPr algn="ctr"/>
-            <a:r>
-              <a:rPr sz="1000" b="0" i="0">
-                <a:solidFill>
-                  <a:srgbClr val="6B7A9A"/>
-                </a:solidFill>
-              </a:rPr>
-              <a:t>Across all incidents (deteriorating trend)</a:t>
-            </a:r>
-          </a:p>
-        </p:txBody>
-      </p:sp>
-      <p:sp>
-        <p:nvSpPr>
-          <p:cNvPr id="27" name="Rectangle 26"/>
-          <p:cNvSpPr/>
-          <p:nvPr/>
-        </p:nvSpPr>
-        <p:spPr>
-          <a:xfrm>
-            <a:off x="4297680" y="3776472"/>
-            <a:ext cx="3657600" cy="54864"/>
-          </a:xfrm>
-          <a:prstGeom prst="rect">
-            <a:avLst/>
-          </a:prstGeom>
-          <a:solidFill>
-            <a:srgbClr val="C8201A"/>
-          </a:solidFill>
-          <a:ln>
-            <a:noFill/>
-          </a:ln>
-        </p:spPr>
-        <p:style>
-          <a:lnRef idx="1">
-            <a:schemeClr val="accent1"/>
-          </a:lnRef>
-          <a:fillRef idx="3">
-            <a:schemeClr val="accent1"/>
-          </a:fillRef>
-          <a:effectRef idx="2">
-            <a:schemeClr val="accent1"/>
-          </a:effectRef>
-          <a:fontRef idx="minor">
-            <a:schemeClr val="lt1"/>
-          </a:fontRef>
-        </p:style>
-        <p:txBody>
-          <a:bodyPr rtlCol="0" anchor="ctr"/>
-          <a:lstStyle/>
-          <a:p>
-            <a:pPr algn="ctr"/>
-          </a:p>
-        </p:txBody>
-      </p:sp>
-      <p:sp>
-        <p:nvSpPr>
-          <p:cNvPr id="28" name="Rectangle 27"/>
-          <p:cNvSpPr/>
-          <p:nvPr/>
-        </p:nvSpPr>
-        <p:spPr>
-          <a:xfrm>
-            <a:off x="4297680" y="3831336"/>
-            <a:ext cx="3657600" cy="2057400"/>
-          </a:xfrm>
-          <a:prstGeom prst="rect">
-            <a:avLst/>
-          </a:prstGeom>
-          <a:solidFill>
-            <a:srgbClr val="EEF2F8"/>
-          </a:solidFill>
-          <a:ln w="10160">
-            <a:solidFill>
-              <a:srgbClr val="1C3461"/>
-            </a:solidFill>
-          </a:ln>
-        </p:spPr>
-        <p:style>
-          <a:lnRef idx="1">
-            <a:schemeClr val="accent1"/>
-          </a:lnRef>
-          <a:fillRef idx="3">
-            <a:schemeClr val="accent1"/>
-          </a:fillRef>
-          <a:effectRef idx="2">
-            <a:schemeClr val="accent1"/>
-          </a:effectRef>
-          <a:fontRef idx="minor">
-            <a:schemeClr val="lt1"/>
-          </a:fontRef>
-        </p:style>
-        <p:txBody>
-          <a:bodyPr rtlCol="0" anchor="ctr"/>
-          <a:lstStyle/>
-          <a:p>
-            <a:pPr algn="ctr"/>
-          </a:p>
-        </p:txBody>
-      </p:sp>
-      <p:sp>
-        <p:nvSpPr>
-          <p:cNvPr id="29" name="TextBox 28"/>
-          <p:cNvSpPr txBox="1"/>
-          <p:nvPr/>
-        </p:nvSpPr>
-        <p:spPr>
-          <a:xfrm>
-            <a:off x="4297680" y="3941064"/>
-            <a:ext cx="3657600" cy="822960"/>
-          </a:xfrm>
-          <a:prstGeom prst="rect">
-            <a:avLst/>
-          </a:prstGeom>
-          <a:noFill/>
-        </p:spPr>
-        <p:txBody>
-          <a:bodyPr wrap="square">
-            <a:spAutoFit/>
-          </a:bodyPr>
-          <a:lstStyle/>
-          <a:p>
-            <a:pPr algn="ctr"/>
-            <a:r>
-              <a:rPr sz="3200" b="1" i="0">
-                <a:solidFill>
-                  <a:srgbClr val="C8201A"/>
-                </a:solidFill>
-              </a:rPr>
-              <a:t>302</a:t>
-            </a:r>
-          </a:p>
-        </p:txBody>
-      </p:sp>
-      <p:sp>
-        <p:nvSpPr>
-          <p:cNvPr id="30" name="TextBox 29"/>
-          <p:cNvSpPr txBox="1"/>
-          <p:nvPr/>
-        </p:nvSpPr>
-        <p:spPr>
-          <a:xfrm>
-            <a:off x="4297680" y="4782312"/>
-            <a:ext cx="3657600" cy="365760"/>
-          </a:xfrm>
-          <a:prstGeom prst="rect">
-            <a:avLst/>
-          </a:prstGeom>
-          <a:noFill/>
-        </p:spPr>
-        <p:txBody>
-          <a:bodyPr wrap="square">
-            <a:spAutoFit/>
-          </a:bodyPr>
-          <a:lstStyle/>
-          <a:p>
-            <a:pPr algn="ctr"/>
-            <a:r>
-              <a:rPr sz="1300" b="1" i="0">
-                <a:solidFill>
-                  <a:srgbClr val="1C3461"/>
-                </a:solidFill>
-              </a:rPr>
-              <a:t>Critical Incidents</a:t>
-            </a:r>
-          </a:p>
-        </p:txBody>
-      </p:sp>
-      <p:sp>
-        <p:nvSpPr>
-          <p:cNvPr id="31" name="TextBox 30"/>
-          <p:cNvSpPr txBox="1"/>
-          <p:nvPr/>
-        </p:nvSpPr>
-        <p:spPr>
-          <a:xfrm>
-            <a:off x="4389120" y="5193792"/>
-            <a:ext cx="3474720" cy="640080"/>
-          </a:xfrm>
-          <a:prstGeom prst="rect">
-            <a:avLst/>
-          </a:prstGeom>
-          <a:noFill/>
-        </p:spPr>
-        <p:txBody>
-          <a:bodyPr wrap="square">
-            <a:spAutoFit/>
-          </a:bodyPr>
-          <a:lstStyle/>
-          <a:p>
-            <a:pPr algn="ctr"/>
-            <a:r>
-              <a:rPr sz="1000" b="0" i="0">
-                <a:solidFill>
-                  <a:srgbClr val="6B7A9A"/>
-                </a:solidFill>
-              </a:rPr>
-              <a:t>50.3% of corpus flagged as critical severity</a:t>
-            </a:r>
-          </a:p>
-        </p:txBody>
-      </p:sp>
-      <p:sp>
-        <p:nvSpPr>
-          <p:cNvPr id="32" name="Rectangle 31"/>
-          <p:cNvSpPr/>
-          <p:nvPr/>
-        </p:nvSpPr>
-        <p:spPr>
-          <a:xfrm>
-            <a:off x="8229600" y="3776472"/>
-            <a:ext cx="3657600" cy="54864"/>
-          </a:xfrm>
-          <a:prstGeom prst="rect">
-            <a:avLst/>
-          </a:prstGeom>
-          <a:solidFill>
-            <a:srgbClr val="0A7A4A"/>
-          </a:solidFill>
-          <a:ln>
-            <a:noFill/>
-          </a:ln>
-        </p:spPr>
-        <p:style>
-          <a:lnRef idx="1">
-            <a:schemeClr val="accent1"/>
-          </a:lnRef>
-          <a:fillRef idx="3">
-            <a:schemeClr val="accent1"/>
-          </a:fillRef>
-          <a:effectRef idx="2">
-            <a:schemeClr val="accent1"/>
-          </a:effectRef>
-          <a:fontRef idx="minor">
-            <a:schemeClr val="lt1"/>
-          </a:fontRef>
-        </p:style>
-        <p:txBody>
-          <a:bodyPr rtlCol="0" anchor="ctr"/>
-          <a:lstStyle/>
-          <a:p>
-            <a:pPr algn="ctr"/>
-          </a:p>
-        </p:txBody>
-      </p:sp>
-      <p:sp>
-        <p:nvSpPr>
-          <p:cNvPr id="33" name="Rectangle 32"/>
-          <p:cNvSpPr/>
-          <p:nvPr/>
-        </p:nvSpPr>
-        <p:spPr>
-          <a:xfrm>
-            <a:off x="8229600" y="3831336"/>
-            <a:ext cx="3657600" cy="2057400"/>
-          </a:xfrm>
-          <a:prstGeom prst="rect">
-            <a:avLst/>
-          </a:prstGeom>
-          <a:solidFill>
-            <a:srgbClr val="EEF2F8"/>
-          </a:solidFill>
-          <a:ln w="10160">
-            <a:solidFill>
-              <a:srgbClr val="1C3461"/>
-            </a:solidFill>
-          </a:ln>
-        </p:spPr>
-        <p:style>
-          <a:lnRef idx="1">
-            <a:schemeClr val="accent1"/>
-          </a:lnRef>
-          <a:fillRef idx="3">
-            <a:schemeClr val="accent1"/>
-          </a:fillRef>
-          <a:effectRef idx="2">
-            <a:schemeClr val="accent1"/>
-          </a:effectRef>
-          <a:fontRef idx="minor">
-            <a:schemeClr val="lt1"/>
-          </a:fontRef>
-        </p:style>
-        <p:txBody>
-          <a:bodyPr rtlCol="0" anchor="ctr"/>
-          <a:lstStyle/>
-          <a:p>
-            <a:pPr algn="ctr"/>
-          </a:p>
-        </p:txBody>
-      </p:sp>
-      <p:sp>
-        <p:nvSpPr>
-          <p:cNvPr id="34" name="TextBox 33"/>
-          <p:cNvSpPr txBox="1"/>
-          <p:nvPr/>
-        </p:nvSpPr>
-        <p:spPr>
-          <a:xfrm>
-            <a:off x="8229600" y="3941064"/>
-            <a:ext cx="3657600" cy="822960"/>
-          </a:xfrm>
-          <a:prstGeom prst="rect">
-            <a:avLst/>
-          </a:prstGeom>
-          <a:noFill/>
-        </p:spPr>
-        <p:txBody>
-          <a:bodyPr wrap="square">
-            <a:spAutoFit/>
-          </a:bodyPr>
-          <a:lstStyle/>
-          <a:p>
-            <a:pPr algn="ctr"/>
-            <a:r>
-              <a:rPr sz="3200" b="1" i="0">
-                <a:solidFill>
-                  <a:srgbClr val="0A7A4A"/>
-                </a:solidFill>
-              </a:rPr>
-              <a:t>4 Agents</a:t>
-            </a:r>
-          </a:p>
-        </p:txBody>
-      </p:sp>
-      <p:sp>
-        <p:nvSpPr>
-          <p:cNvPr id="35" name="TextBox 34"/>
-          <p:cNvSpPr txBox="1"/>
-          <p:nvPr/>
-        </p:nvSpPr>
-        <p:spPr>
-          <a:xfrm>
-            <a:off x="8229600" y="4782312"/>
-            <a:ext cx="3657600" cy="365760"/>
-          </a:xfrm>
-          <a:prstGeom prst="rect">
-            <a:avLst/>
-          </a:prstGeom>
-          <a:noFill/>
-        </p:spPr>
-        <p:txBody>
-          <a:bodyPr wrap="square">
-            <a:spAutoFit/>
-          </a:bodyPr>
-          <a:lstStyle/>
-          <a:p>
-            <a:pPr algn="ctr"/>
-            <a:r>
-              <a:rPr sz="1300" b="1" i="0">
-                <a:solidFill>
-                  <a:srgbClr val="1C3461"/>
-                </a:solidFill>
-              </a:rPr>
-              <a:t>Multi-Agent</a:t>
-            </a:r>
-          </a:p>
-        </p:txBody>
-      </p:sp>
-      <p:sp>
-        <p:nvSpPr>
-          <p:cNvPr id="36" name="TextBox 35"/>
-          <p:cNvSpPr txBox="1"/>
-          <p:nvPr/>
-        </p:nvSpPr>
-        <p:spPr>
-          <a:xfrm>
-            <a:off x="8321040" y="5193792"/>
-            <a:ext cx="3474720" cy="640080"/>
-          </a:xfrm>
-          <a:prstGeom prst="rect">
-            <a:avLst/>
-          </a:prstGeom>
-          <a:noFill/>
-        </p:spPr>
-        <p:txBody>
-          <a:bodyPr wrap="square">
-            <a:spAutoFit/>
-          </a:bodyPr>
-          <a:lstStyle/>
-          <a:p>
-            <a:pPr algn="ctr"/>
-            <a:r>
-              <a:rPr sz="1000" b="0" i="0">
-                <a:solidFill>
-                  <a:srgbClr val="6B7A9A"/>
-                </a:solidFill>
-              </a:rPr>
-              <a:t>Parallel + A2A escalation in ~22s</a:t>
-            </a:r>
-          </a:p>
-        </p:txBody>
-      </p:sp>
-    </p:spTree>
-  </p:cSld>
-  <p:clrMapOvr>
-    <a:masterClrMapping/>
-  </p:clrMapOvr>
-</p:sld>
-</file>
-
-<file path=ppt/slides/slide14.xml><?xml version="1.0" encoding="utf-8"?>
 <p:sld xmlns:a="http://schemas.openxmlformats.org/drawingml/2006/main" xmlns:p="http://schemas.openxmlformats.org/presentationml/2006/main" xmlns:r="http://schemas.openxmlformats.org/officeDocument/2006/relationships">
   <p:cSld>
     <p:bg>

</xml_diff>

<commit_message>
Update PPT architecture slide to match TECHNICAL_DOCUMENT.md
Slide 4 now faithfully reflects the §2 architecture diagram:
- Layer 1: FRONTEND SPA — 5 tab buttons shown as individual boxes
- Layer 2: FASTAPI /api/v1 — 4 route groups as individual labeled cells
           (/search, /recommendations, /agents/analyze, /analytics)
- Layer 3: Service split — RAG Search | RAG Generate | Orchestrator | Analytics
- Layer 4: CORE SERVICES — HybridSearch(BM25+RRF) | RiskScoring | Guardrails | TokenOptimizer
- Layer 5a (left):  NUMPY VECTOR STORE — embeddings.npy + documents.json + BM25 + dimension guard
- Layer 5b (right): OPENAI GPT-4o-mini — via keygateway, SSL-off, 3 uses listed
- Layer 6: DATA LAYER — CSV → Preprocessing → Chunking → Embeddings → VectorStore

Co-Authored-By: Claude Sonnet 4.6 <noreply@anthropic.com>
</commit_message>
<xml_diff>
--- a/SC_Risk_Intelligence_PPT.pptx
+++ b/SC_Risk_Intelligence_PPT.pptx
@@ -11218,7 +11218,7 @@
                   <a:srgbClr val="C8D3E8"/>
                 </a:solidFill>
               </a:rPr>
-              <a:t>Layered microservice design — each layer independently replaceable</a:t>
+              <a:t>Layered microservice design (TECHNICAL_DOCUMENT.md §2) — each layer independently replaceable</a:t>
             </a:r>
           </a:p>
         </p:txBody>
@@ -11275,7 +11275,7 @@
         <p:spPr>
           <a:xfrm>
             <a:off x="365760" y="1389888"/>
-            <a:ext cx="11430000" cy="777240"/>
+            <a:ext cx="11430000" cy="530352"/>
           </a:xfrm>
           <a:prstGeom prst="rect">
             <a:avLst/>
@@ -11317,8 +11317,8 @@
         </p:nvSpPr>
         <p:spPr>
           <a:xfrm>
-            <a:off x="502920" y="1444752"/>
-            <a:ext cx="2926080" cy="347472"/>
+            <a:off x="502920" y="1408176"/>
+            <a:ext cx="4572000" cy="274320"/>
           </a:xfrm>
           <a:prstGeom prst="rect">
             <a:avLst/>
@@ -11333,66 +11333,32 @@
           <a:p>
             <a:pPr algn="l"/>
             <a:r>
-              <a:rPr sz="1050" b="1" i="0">
-                <a:solidFill>
-                  <a:srgbClr val="F05A28"/>
-                </a:solidFill>
-              </a:rPr>
-              <a:t>FRONTEND  (5-Tab SPA)</a:t>
-            </a:r>
-          </a:p>
-        </p:txBody>
-      </p:sp>
-      <p:sp>
-        <p:nvSpPr>
-          <p:cNvPr id="9" name="TextBox 8"/>
-          <p:cNvSpPr txBox="1"/>
-          <p:nvPr/>
-        </p:nvSpPr>
-        <p:spPr>
-          <a:xfrm>
-            <a:off x="3474720" y="1444752"/>
-            <a:ext cx="8229600" cy="658368"/>
-          </a:xfrm>
-          <a:prstGeom prst="rect">
-            <a:avLst/>
-          </a:prstGeom>
-          <a:noFill/>
-        </p:spPr>
-        <p:txBody>
-          <a:bodyPr wrap="square">
-            <a:spAutoFit/>
-          </a:bodyPr>
-          <a:lstStyle/>
-          <a:p>
-            <a:pPr algn="l"/>
-            <a:r>
-              <a:rPr sz="1000" b="0" i="0">
+              <a:rPr sz="1000" b="1" i="0">
                 <a:solidFill>
                   <a:srgbClr val="FFFFFF"/>
                 </a:solidFill>
               </a:rPr>
-              <a:t>Search  |  Recommendations  |  Multi-Agent  |  Dashboard  |  Anomalies</a:t>
-            </a:r>
-          </a:p>
-        </p:txBody>
-      </p:sp>
-      <p:sp>
-        <p:nvSpPr>
-          <p:cNvPr id="10" name="Rectangle 9"/>
+              <a:t>FRONTEND  (5-Tab SPA — Zero dependency HTML/CSS/JS)</a:t>
+            </a:r>
+          </a:p>
+        </p:txBody>
+      </p:sp>
+      <p:sp>
+        <p:nvSpPr>
+          <p:cNvPr id="9" name="Rectangle 8"/>
           <p:cNvSpPr/>
           <p:nvPr/>
         </p:nvSpPr>
         <p:spPr>
           <a:xfrm>
-            <a:off x="365760" y="2240280"/>
-            <a:ext cx="11430000" cy="777240"/>
-          </a:xfrm>
-          <a:prstGeom prst="rect">
-            <a:avLst/>
-          </a:prstGeom>
-          <a:solidFill>
-            <a:srgbClr val="1C3461"/>
+            <a:off x="5212080" y="1435608"/>
+            <a:ext cx="1188720" cy="384048"/>
+          </a:xfrm>
+          <a:prstGeom prst="rect">
+            <a:avLst/>
+          </a:prstGeom>
+          <a:solidFill>
+            <a:srgbClr val="FFFFFF"/>
           </a:solidFill>
           <a:ln>
             <a:noFill/>
@@ -11422,88 +11388,54 @@
       </p:sp>
       <p:sp>
         <p:nvSpPr>
-          <p:cNvPr id="11" name="TextBox 10"/>
-          <p:cNvSpPr txBox="1"/>
-          <p:nvPr/>
-        </p:nvSpPr>
-        <p:spPr>
-          <a:xfrm>
-            <a:off x="502920" y="2295144"/>
-            <a:ext cx="2926080" cy="347472"/>
-          </a:xfrm>
-          <a:prstGeom prst="rect">
-            <a:avLst/>
-          </a:prstGeom>
-          <a:noFill/>
-        </p:spPr>
-        <p:txBody>
-          <a:bodyPr wrap="square">
-            <a:spAutoFit/>
-          </a:bodyPr>
-          <a:lstStyle/>
-          <a:p>
-            <a:pPr algn="l"/>
-            <a:r>
-              <a:rPr sz="1050" b="1" i="0">
+          <p:cNvPr id="10" name="TextBox 9"/>
+          <p:cNvSpPr txBox="1"/>
+          <p:nvPr/>
+        </p:nvSpPr>
+        <p:spPr>
+          <a:xfrm>
+            <a:off x="5212080" y="1435608"/>
+            <a:ext cx="1188720" cy="384048"/>
+          </a:xfrm>
+          <a:prstGeom prst="rect">
+            <a:avLst/>
+          </a:prstGeom>
+          <a:noFill/>
+        </p:spPr>
+        <p:txBody>
+          <a:bodyPr wrap="square">
+            <a:spAutoFit/>
+          </a:bodyPr>
+          <a:lstStyle/>
+          <a:p>
+            <a:pPr algn="ctr"/>
+            <a:r>
+              <a:rPr sz="900" b="1" i="0">
                 <a:solidFill>
                   <a:srgbClr val="F05A28"/>
                 </a:solidFill>
               </a:rPr>
-              <a:t>FASTAPI  API LAYER  /api/v1</a:t>
-            </a:r>
-          </a:p>
-        </p:txBody>
-      </p:sp>
-      <p:sp>
-        <p:nvSpPr>
-          <p:cNvPr id="12" name="TextBox 11"/>
-          <p:cNvSpPr txBox="1"/>
-          <p:nvPr/>
-        </p:nvSpPr>
-        <p:spPr>
-          <a:xfrm>
-            <a:off x="3474720" y="2295144"/>
-            <a:ext cx="8229600" cy="658368"/>
-          </a:xfrm>
-          <a:prstGeom prst="rect">
-            <a:avLst/>
-          </a:prstGeom>
-          <a:noFill/>
-        </p:spPr>
-        <p:txBody>
-          <a:bodyPr wrap="square">
-            <a:spAutoFit/>
-          </a:bodyPr>
-          <a:lstStyle/>
-          <a:p>
-            <a:pPr algn="l"/>
-            <a:r>
-              <a:rPr sz="1000" b="0" i="0">
-                <a:solidFill>
-                  <a:srgbClr val="FFFFFF"/>
-                </a:solidFill>
-              </a:rPr>
-              <a:t>/search   /recommendations   /agents/analyze   /analytics/dashboard   /analytics/anomalies</a:t>
-            </a:r>
-          </a:p>
-        </p:txBody>
-      </p:sp>
-      <p:sp>
-        <p:nvSpPr>
-          <p:cNvPr id="13" name="Rectangle 12"/>
+              <a:t>Search</a:t>
+            </a:r>
+          </a:p>
+        </p:txBody>
+      </p:sp>
+      <p:sp>
+        <p:nvSpPr>
+          <p:cNvPr id="11" name="Rectangle 10"/>
           <p:cNvSpPr/>
           <p:nvPr/>
         </p:nvSpPr>
         <p:spPr>
           <a:xfrm>
-            <a:off x="365760" y="3090672"/>
-            <a:ext cx="11430000" cy="777240"/>
-          </a:xfrm>
-          <a:prstGeom prst="rect">
-            <a:avLst/>
-          </a:prstGeom>
-          <a:solidFill>
-            <a:srgbClr val="243D72"/>
+            <a:off x="6510528" y="1435608"/>
+            <a:ext cx="1188720" cy="384048"/>
+          </a:xfrm>
+          <a:prstGeom prst="rect">
+            <a:avLst/>
+          </a:prstGeom>
+          <a:solidFill>
+            <a:srgbClr val="FFFFFF"/>
           </a:solidFill>
           <a:ln>
             <a:noFill/>
@@ -11533,88 +11465,54 @@
       </p:sp>
       <p:sp>
         <p:nvSpPr>
-          <p:cNvPr id="14" name="TextBox 13"/>
-          <p:cNvSpPr txBox="1"/>
-          <p:nvPr/>
-        </p:nvSpPr>
-        <p:spPr>
-          <a:xfrm>
-            <a:off x="502920" y="3145536"/>
-            <a:ext cx="2926080" cy="347472"/>
-          </a:xfrm>
-          <a:prstGeom prst="rect">
-            <a:avLst/>
-          </a:prstGeom>
-          <a:noFill/>
-        </p:spPr>
-        <p:txBody>
-          <a:bodyPr wrap="square">
-            <a:spAutoFit/>
-          </a:bodyPr>
-          <a:lstStyle/>
-          <a:p>
-            <a:pPr algn="l"/>
-            <a:r>
-              <a:rPr sz="1050" b="1" i="0">
+          <p:cNvPr id="12" name="TextBox 11"/>
+          <p:cNvSpPr txBox="1"/>
+          <p:nvPr/>
+        </p:nvSpPr>
+        <p:spPr>
+          <a:xfrm>
+            <a:off x="6510528" y="1435608"/>
+            <a:ext cx="1188720" cy="384048"/>
+          </a:xfrm>
+          <a:prstGeom prst="rect">
+            <a:avLst/>
+          </a:prstGeom>
+          <a:noFill/>
+        </p:spPr>
+        <p:txBody>
+          <a:bodyPr wrap="square">
+            <a:spAutoFit/>
+          </a:bodyPr>
+          <a:lstStyle/>
+          <a:p>
+            <a:pPr algn="ctr"/>
+            <a:r>
+              <a:rPr sz="900" b="1" i="0">
                 <a:solidFill>
                   <a:srgbClr val="F05A28"/>
                 </a:solidFill>
               </a:rPr>
-              <a:t>CORE SERVICES</a:t>
-            </a:r>
-          </a:p>
-        </p:txBody>
-      </p:sp>
-      <p:sp>
-        <p:nvSpPr>
-          <p:cNvPr id="15" name="TextBox 14"/>
-          <p:cNvSpPr txBox="1"/>
-          <p:nvPr/>
-        </p:nvSpPr>
-        <p:spPr>
-          <a:xfrm>
-            <a:off x="3474720" y="3145536"/>
-            <a:ext cx="8229600" cy="658368"/>
-          </a:xfrm>
-          <a:prstGeom prst="rect">
-            <a:avLst/>
-          </a:prstGeom>
-          <a:noFill/>
-        </p:spPr>
-        <p:txBody>
-          <a:bodyPr wrap="square">
-            <a:spAutoFit/>
-          </a:bodyPr>
-          <a:lstStyle/>
-          <a:p>
-            <a:pPr algn="l"/>
-            <a:r>
-              <a:rPr sz="1000" b="0" i="0">
-                <a:solidFill>
-                  <a:srgbClr val="FFFFFF"/>
-                </a:solidFill>
-              </a:rPr>
-              <a:t>HybridSearch (BM25 + RRF)   |   RiskScoring   |   Guardrails   |   TokenOptimizer</a:t>
-            </a:r>
-          </a:p>
-        </p:txBody>
-      </p:sp>
-      <p:sp>
-        <p:nvSpPr>
-          <p:cNvPr id="16" name="Rectangle 15"/>
+              <a:t>Recommendations</a:t>
+            </a:r>
+          </a:p>
+        </p:txBody>
+      </p:sp>
+      <p:sp>
+        <p:nvSpPr>
+          <p:cNvPr id="13" name="Rectangle 12"/>
           <p:cNvSpPr/>
           <p:nvPr/>
         </p:nvSpPr>
         <p:spPr>
           <a:xfrm>
-            <a:off x="365760" y="3941064"/>
-            <a:ext cx="11430000" cy="777240"/>
-          </a:xfrm>
-          <a:prstGeom prst="rect">
-            <a:avLst/>
-          </a:prstGeom>
-          <a:solidFill>
-            <a:srgbClr val="2E4A80"/>
+            <a:off x="7808976" y="1435608"/>
+            <a:ext cx="1188720" cy="384048"/>
+          </a:xfrm>
+          <a:prstGeom prst="rect">
+            <a:avLst/>
+          </a:prstGeom>
+          <a:solidFill>
+            <a:srgbClr val="FFFFFF"/>
           </a:solidFill>
           <a:ln>
             <a:noFill/>
@@ -11644,88 +11542,54 @@
       </p:sp>
       <p:sp>
         <p:nvSpPr>
-          <p:cNvPr id="17" name="TextBox 16"/>
-          <p:cNvSpPr txBox="1"/>
-          <p:nvPr/>
-        </p:nvSpPr>
-        <p:spPr>
-          <a:xfrm>
-            <a:off x="502920" y="3995928"/>
-            <a:ext cx="2926080" cy="347472"/>
-          </a:xfrm>
-          <a:prstGeom prst="rect">
-            <a:avLst/>
-          </a:prstGeom>
-          <a:noFill/>
-        </p:spPr>
-        <p:txBody>
-          <a:bodyPr wrap="square">
-            <a:spAutoFit/>
-          </a:bodyPr>
-          <a:lstStyle/>
-          <a:p>
-            <a:pPr algn="l"/>
-            <a:r>
-              <a:rPr sz="1050" b="1" i="0">
+          <p:cNvPr id="14" name="TextBox 13"/>
+          <p:cNvSpPr txBox="1"/>
+          <p:nvPr/>
+        </p:nvSpPr>
+        <p:spPr>
+          <a:xfrm>
+            <a:off x="7808976" y="1435608"/>
+            <a:ext cx="1188720" cy="384048"/>
+          </a:xfrm>
+          <a:prstGeom prst="rect">
+            <a:avLst/>
+          </a:prstGeom>
+          <a:noFill/>
+        </p:spPr>
+        <p:txBody>
+          <a:bodyPr wrap="square">
+            <a:spAutoFit/>
+          </a:bodyPr>
+          <a:lstStyle/>
+          <a:p>
+            <a:pPr algn="ctr"/>
+            <a:r>
+              <a:rPr sz="900" b="1" i="0">
                 <a:solidFill>
                   <a:srgbClr val="F05A28"/>
                 </a:solidFill>
               </a:rPr>
-              <a:t>BUSINESS SERVICES</a:t>
-            </a:r>
-          </a:p>
-        </p:txBody>
-      </p:sp>
-      <p:sp>
-        <p:nvSpPr>
-          <p:cNvPr id="18" name="TextBox 17"/>
-          <p:cNvSpPr txBox="1"/>
-          <p:nvPr/>
-        </p:nvSpPr>
-        <p:spPr>
-          <a:xfrm>
-            <a:off x="3474720" y="3995928"/>
-            <a:ext cx="8229600" cy="658368"/>
-          </a:xfrm>
-          <a:prstGeom prst="rect">
-            <a:avLst/>
-          </a:prstGeom>
-          <a:noFill/>
-        </p:spPr>
-        <p:txBody>
-          <a:bodyPr wrap="square">
-            <a:spAutoFit/>
-          </a:bodyPr>
-          <a:lstStyle/>
-          <a:p>
-            <a:pPr algn="l"/>
-            <a:r>
-              <a:rPr sz="1000" b="0" i="0">
-                <a:solidFill>
-                  <a:srgbClr val="FFFFFF"/>
-                </a:solidFill>
-              </a:rPr>
-              <a:t>RAG Service   |   Anomaly Detection (IsolationForest)   |   Evaluation (DeepEval + LLM Judge)</a:t>
-            </a:r>
-          </a:p>
-        </p:txBody>
-      </p:sp>
-      <p:sp>
-        <p:nvSpPr>
-          <p:cNvPr id="19" name="Rectangle 18"/>
+              <a:t>Multi-Agent</a:t>
+            </a:r>
+          </a:p>
+        </p:txBody>
+      </p:sp>
+      <p:sp>
+        <p:nvSpPr>
+          <p:cNvPr id="15" name="Rectangle 14"/>
           <p:cNvSpPr/>
           <p:nvPr/>
         </p:nvSpPr>
         <p:spPr>
           <a:xfrm>
-            <a:off x="365760" y="4791456"/>
-            <a:ext cx="11430000" cy="777240"/>
-          </a:xfrm>
-          <a:prstGeom prst="rect">
-            <a:avLst/>
-          </a:prstGeom>
-          <a:solidFill>
-            <a:srgbClr val="3A5690"/>
+            <a:off x="9107424" y="1435608"/>
+            <a:ext cx="1188720" cy="384048"/>
+          </a:xfrm>
+          <a:prstGeom prst="rect">
+            <a:avLst/>
+          </a:prstGeom>
+          <a:solidFill>
+            <a:srgbClr val="FFFFFF"/>
           </a:solidFill>
           <a:ln>
             <a:noFill/>
@@ -11755,88 +11619,54 @@
       </p:sp>
       <p:sp>
         <p:nvSpPr>
-          <p:cNvPr id="20" name="TextBox 19"/>
-          <p:cNvSpPr txBox="1"/>
-          <p:nvPr/>
-        </p:nvSpPr>
-        <p:spPr>
-          <a:xfrm>
-            <a:off x="502920" y="4846320"/>
-            <a:ext cx="2926080" cy="347472"/>
-          </a:xfrm>
-          <a:prstGeom prst="rect">
-            <a:avLst/>
-          </a:prstGeom>
-          <a:noFill/>
-        </p:spPr>
-        <p:txBody>
-          <a:bodyPr wrap="square">
-            <a:spAutoFit/>
-          </a:bodyPr>
-          <a:lstStyle/>
-          <a:p>
-            <a:pPr algn="l"/>
-            <a:r>
-              <a:rPr sz="1050" b="1" i="0">
+          <p:cNvPr id="16" name="TextBox 15"/>
+          <p:cNvSpPr txBox="1"/>
+          <p:nvPr/>
+        </p:nvSpPr>
+        <p:spPr>
+          <a:xfrm>
+            <a:off x="9107424" y="1435608"/>
+            <a:ext cx="1188720" cy="384048"/>
+          </a:xfrm>
+          <a:prstGeom prst="rect">
+            <a:avLst/>
+          </a:prstGeom>
+          <a:noFill/>
+        </p:spPr>
+        <p:txBody>
+          <a:bodyPr wrap="square">
+            <a:spAutoFit/>
+          </a:bodyPr>
+          <a:lstStyle/>
+          <a:p>
+            <a:pPr algn="ctr"/>
+            <a:r>
+              <a:rPr sz="900" b="1" i="0">
                 <a:solidFill>
                   <a:srgbClr val="F05A28"/>
                 </a:solidFill>
               </a:rPr>
-              <a:t>MULTI-AGENT SYSTEM</a:t>
-            </a:r>
-          </a:p>
-        </p:txBody>
-      </p:sp>
-      <p:sp>
-        <p:nvSpPr>
-          <p:cNvPr id="21" name="TextBox 20"/>
-          <p:cNvSpPr txBox="1"/>
-          <p:nvPr/>
-        </p:nvSpPr>
-        <p:spPr>
-          <a:xfrm>
-            <a:off x="3474720" y="4846320"/>
-            <a:ext cx="8229600" cy="658368"/>
-          </a:xfrm>
-          <a:prstGeom prst="rect">
-            <a:avLst/>
-          </a:prstGeom>
-          <a:noFill/>
-        </p:spPr>
-        <p:txBody>
-          <a:bodyPr wrap="square">
-            <a:spAutoFit/>
-          </a:bodyPr>
-          <a:lstStyle/>
-          <a:p>
-            <a:pPr algn="l"/>
-            <a:r>
-              <a:rPr sz="1000" b="0" i="0">
-                <a:solidFill>
-                  <a:srgbClr val="FFFFFF"/>
-                </a:solidFill>
-              </a:rPr>
-              <a:t>SupplierRiskAgent  ·  ShipmentAgent  ·  InventoryAgent  →  RecommendationAgent  [A2A Escalation]</a:t>
-            </a:r>
-          </a:p>
-        </p:txBody>
-      </p:sp>
-      <p:sp>
-        <p:nvSpPr>
-          <p:cNvPr id="22" name="Rectangle 21"/>
+              <a:t>Dashboard</a:t>
+            </a:r>
+          </a:p>
+        </p:txBody>
+      </p:sp>
+      <p:sp>
+        <p:nvSpPr>
+          <p:cNvPr id="17" name="Rectangle 16"/>
           <p:cNvSpPr/>
           <p:nvPr/>
         </p:nvSpPr>
         <p:spPr>
           <a:xfrm>
-            <a:off x="365760" y="5641848"/>
-            <a:ext cx="11430000" cy="777240"/>
-          </a:xfrm>
-          <a:prstGeom prst="rect">
-            <a:avLst/>
-          </a:prstGeom>
-          <a:solidFill>
-            <a:srgbClr val="182A50"/>
+            <a:off x="10405872" y="1435608"/>
+            <a:ext cx="1188720" cy="384048"/>
+          </a:xfrm>
+          <a:prstGeom prst="rect">
+            <a:avLst/>
+          </a:prstGeom>
+          <a:solidFill>
+            <a:srgbClr val="FFFFFF"/>
           </a:solidFill>
           <a:ln>
             <a:noFill/>
@@ -11866,93 +11696,91 @@
       </p:sp>
       <p:sp>
         <p:nvSpPr>
-          <p:cNvPr id="23" name="TextBox 22"/>
-          <p:cNvSpPr txBox="1"/>
-          <p:nvPr/>
-        </p:nvSpPr>
-        <p:spPr>
-          <a:xfrm>
-            <a:off x="502920" y="5696712"/>
-            <a:ext cx="2926080" cy="347472"/>
-          </a:xfrm>
-          <a:prstGeom prst="rect">
-            <a:avLst/>
-          </a:prstGeom>
-          <a:noFill/>
-        </p:spPr>
-        <p:txBody>
-          <a:bodyPr wrap="square">
-            <a:spAutoFit/>
-          </a:bodyPr>
-          <a:lstStyle/>
-          <a:p>
-            <a:pPr algn="l"/>
-            <a:r>
-              <a:rPr sz="1050" b="1" i="0">
-                <a:solidFill>
-                  <a:srgbClr val="C8D3E8"/>
-                </a:solidFill>
-              </a:rPr>
-              <a:t>DATA LAYER</a:t>
-            </a:r>
-          </a:p>
-        </p:txBody>
-      </p:sp>
-      <p:sp>
-        <p:nvSpPr>
-          <p:cNvPr id="24" name="TextBox 23"/>
-          <p:cNvSpPr txBox="1"/>
-          <p:nvPr/>
-        </p:nvSpPr>
-        <p:spPr>
-          <a:xfrm>
-            <a:off x="3474720" y="5696712"/>
-            <a:ext cx="8229600" cy="658368"/>
-          </a:xfrm>
-          <a:prstGeom prst="rect">
-            <a:avLst/>
-          </a:prstGeom>
-          <a:noFill/>
-        </p:spPr>
-        <p:txBody>
-          <a:bodyPr wrap="square">
-            <a:spAutoFit/>
-          </a:bodyPr>
-          <a:lstStyle/>
-          <a:p>
-            <a:pPr algn="l"/>
-            <a:r>
-              <a:rPr sz="1000" b="0" i="0">
-                <a:solidFill>
-                  <a:srgbClr val="C8D3E8"/>
-                </a:solidFill>
-              </a:rPr>
-              <a:t>all-MiniLM-L6-v2 Embeddings   |   NumPy VectorStore (embeddings.npy)   |   BM25 Index   |   supply_chain_data.csv</a:t>
-            </a:r>
-          </a:p>
-        </p:txBody>
-      </p:sp>
-      <p:sp>
-        <p:nvSpPr>
-          <p:cNvPr id="25" name="Rectangle 24"/>
+          <p:cNvPr id="18" name="TextBox 17"/>
+          <p:cNvSpPr txBox="1"/>
+          <p:nvPr/>
+        </p:nvSpPr>
+        <p:spPr>
+          <a:xfrm>
+            <a:off x="10405872" y="1435608"/>
+            <a:ext cx="1188720" cy="384048"/>
+          </a:xfrm>
+          <a:prstGeom prst="rect">
+            <a:avLst/>
+          </a:prstGeom>
+          <a:noFill/>
+        </p:spPr>
+        <p:txBody>
+          <a:bodyPr wrap="square">
+            <a:spAutoFit/>
+          </a:bodyPr>
+          <a:lstStyle/>
+          <a:p>
+            <a:pPr algn="ctr"/>
+            <a:r>
+              <a:rPr sz="900" b="1" i="0">
+                <a:solidFill>
+                  <a:srgbClr val="F05A28"/>
+                </a:solidFill>
+              </a:rPr>
+              <a:t>Anomalies</a:t>
+            </a:r>
+          </a:p>
+        </p:txBody>
+      </p:sp>
+      <p:sp>
+        <p:nvSpPr>
+          <p:cNvPr id="19" name="TextBox 18"/>
+          <p:cNvSpPr txBox="1"/>
+          <p:nvPr/>
+        </p:nvSpPr>
+        <p:spPr>
+          <a:xfrm>
+            <a:off x="5486400" y="1938528"/>
+            <a:ext cx="2286000" cy="256032"/>
+          </a:xfrm>
+          <a:prstGeom prst="rect">
+            <a:avLst/>
+          </a:prstGeom>
+          <a:noFill/>
+        </p:spPr>
+        <p:txBody>
+          <a:bodyPr wrap="square">
+            <a:spAutoFit/>
+          </a:bodyPr>
+          <a:lstStyle/>
+          <a:p>
+            <a:pPr algn="ctr"/>
+            <a:r>
+              <a:rPr sz="900" b="1" i="0">
+                <a:solidFill>
+                  <a:srgbClr val="F05A28"/>
+                </a:solidFill>
+              </a:rPr>
+              <a:t>▼  HTTP / REST</a:t>
+            </a:r>
+          </a:p>
+        </p:txBody>
+      </p:sp>
+      <p:sp>
+        <p:nvSpPr>
+          <p:cNvPr id="20" name="Rectangle 19"/>
           <p:cNvSpPr/>
           <p:nvPr/>
         </p:nvSpPr>
         <p:spPr>
           <a:xfrm>
-            <a:off x="9875520" y="2743200"/>
-            <a:ext cx="1920240" cy="1371600"/>
-          </a:xfrm>
-          <a:prstGeom prst="rect">
-            <a:avLst/>
-          </a:prstGeom>
-          <a:solidFill>
-            <a:srgbClr val="F05A28"/>
-          </a:solidFill>
-          <a:ln w="19050">
-            <a:solidFill>
-              <a:srgbClr val="FFFFFF"/>
-            </a:solidFill>
+            <a:off x="365760" y="2212848"/>
+            <a:ext cx="11430000" cy="548640"/>
+          </a:xfrm>
+          <a:prstGeom prst="rect">
+            <a:avLst/>
+          </a:prstGeom>
+          <a:solidFill>
+            <a:srgbClr val="1C3461"/>
+          </a:solidFill>
+          <a:ln>
+            <a:noFill/>
           </a:ln>
         </p:spPr>
         <p:style>
@@ -11979,36 +11807,1466 @@
       </p:sp>
       <p:sp>
         <p:nvSpPr>
-          <p:cNvPr id="26" name="TextBox 25"/>
-          <p:cNvSpPr txBox="1"/>
-          <p:nvPr/>
-        </p:nvSpPr>
-        <p:spPr>
-          <a:xfrm>
-            <a:off x="9921240" y="2788920"/>
-            <a:ext cx="1828800" cy="1280160"/>
-          </a:xfrm>
-          <a:prstGeom prst="rect">
-            <a:avLst/>
-          </a:prstGeom>
-          <a:noFill/>
-        </p:spPr>
-        <p:txBody>
-          <a:bodyPr wrap="square">
-            <a:spAutoFit/>
-          </a:bodyPr>
-          <a:lstStyle/>
-          <a:p>
-            <a:pPr algn="ctr"/>
-            <a:r>
-              <a:rPr sz="1050" b="1" i="0">
+          <p:cNvPr id="21" name="TextBox 20"/>
+          <p:cNvSpPr txBox="1"/>
+          <p:nvPr/>
+        </p:nvSpPr>
+        <p:spPr>
+          <a:xfrm>
+            <a:off x="502920" y="2231136"/>
+            <a:ext cx="4114800" cy="274320"/>
+          </a:xfrm>
+          <a:prstGeom prst="rect">
+            <a:avLst/>
+          </a:prstGeom>
+          <a:noFill/>
+        </p:spPr>
+        <p:txBody>
+          <a:bodyPr wrap="square">
+            <a:spAutoFit/>
+          </a:bodyPr>
+          <a:lstStyle/>
+          <a:p>
+            <a:pPr algn="l"/>
+            <a:r>
+              <a:rPr sz="1000" b="1" i="0">
+                <a:solidFill>
+                  <a:srgbClr val="F05A28"/>
+                </a:solidFill>
+              </a:rPr>
+              <a:t>FASTAPI APPLICATION  /api/v1  (9 endpoints)</a:t>
+            </a:r>
+          </a:p>
+        </p:txBody>
+      </p:sp>
+      <p:sp>
+        <p:nvSpPr>
+          <p:cNvPr id="22" name="Rectangle 21"/>
+          <p:cNvSpPr/>
+          <p:nvPr/>
+        </p:nvSpPr>
+        <p:spPr>
+          <a:xfrm>
+            <a:off x="4572000" y="2258568"/>
+            <a:ext cx="1664208" cy="347472"/>
+          </a:xfrm>
+          <a:prstGeom prst="rect">
+            <a:avLst/>
+          </a:prstGeom>
+          <a:solidFill>
+            <a:srgbClr val="243D72"/>
+          </a:solidFill>
+          <a:ln w="10160">
+            <a:solidFill>
+              <a:srgbClr val="F05A28"/>
+            </a:solidFill>
+          </a:ln>
+        </p:spPr>
+        <p:style>
+          <a:lnRef idx="1">
+            <a:schemeClr val="accent1"/>
+          </a:lnRef>
+          <a:fillRef idx="3">
+            <a:schemeClr val="accent1"/>
+          </a:fillRef>
+          <a:effectRef idx="2">
+            <a:schemeClr val="accent1"/>
+          </a:effectRef>
+          <a:fontRef idx="minor">
+            <a:schemeClr val="lt1"/>
+          </a:fontRef>
+        </p:style>
+        <p:txBody>
+          <a:bodyPr rtlCol="0" anchor="ctr"/>
+          <a:lstStyle/>
+          <a:p>
+            <a:pPr algn="ctr"/>
+          </a:p>
+        </p:txBody>
+      </p:sp>
+      <p:sp>
+        <p:nvSpPr>
+          <p:cNvPr id="23" name="TextBox 22"/>
+          <p:cNvSpPr txBox="1"/>
+          <p:nvPr/>
+        </p:nvSpPr>
+        <p:spPr>
+          <a:xfrm>
+            <a:off x="4572000" y="2258568"/>
+            <a:ext cx="1664208" cy="347472"/>
+          </a:xfrm>
+          <a:prstGeom prst="rect">
+            <a:avLst/>
+          </a:prstGeom>
+          <a:noFill/>
+        </p:spPr>
+        <p:txBody>
+          <a:bodyPr wrap="square">
+            <a:spAutoFit/>
+          </a:bodyPr>
+          <a:lstStyle/>
+          <a:p>
+            <a:pPr algn="ctr"/>
+            <a:r>
+              <a:rPr sz="900" b="1" i="0">
                 <a:solidFill>
                   <a:srgbClr val="FFFFFF"/>
                 </a:solidFill>
               </a:rPr>
-              <a:t>OpenAI
-GPT-4o-mini
-via Gateway</a:t>
+              <a:t>/search</a:t>
+            </a:r>
+          </a:p>
+        </p:txBody>
+      </p:sp>
+      <p:sp>
+        <p:nvSpPr>
+          <p:cNvPr id="24" name="Rectangle 23"/>
+          <p:cNvSpPr/>
+          <p:nvPr/>
+        </p:nvSpPr>
+        <p:spPr>
+          <a:xfrm>
+            <a:off x="6373368" y="2258568"/>
+            <a:ext cx="1664208" cy="347472"/>
+          </a:xfrm>
+          <a:prstGeom prst="rect">
+            <a:avLst/>
+          </a:prstGeom>
+          <a:solidFill>
+            <a:srgbClr val="243D72"/>
+          </a:solidFill>
+          <a:ln w="10160">
+            <a:solidFill>
+              <a:srgbClr val="F05A28"/>
+            </a:solidFill>
+          </a:ln>
+        </p:spPr>
+        <p:style>
+          <a:lnRef idx="1">
+            <a:schemeClr val="accent1"/>
+          </a:lnRef>
+          <a:fillRef idx="3">
+            <a:schemeClr val="accent1"/>
+          </a:fillRef>
+          <a:effectRef idx="2">
+            <a:schemeClr val="accent1"/>
+          </a:effectRef>
+          <a:fontRef idx="minor">
+            <a:schemeClr val="lt1"/>
+          </a:fontRef>
+        </p:style>
+        <p:txBody>
+          <a:bodyPr rtlCol="0" anchor="ctr"/>
+          <a:lstStyle/>
+          <a:p>
+            <a:pPr algn="ctr"/>
+          </a:p>
+        </p:txBody>
+      </p:sp>
+      <p:sp>
+        <p:nvSpPr>
+          <p:cNvPr id="25" name="TextBox 24"/>
+          <p:cNvSpPr txBox="1"/>
+          <p:nvPr/>
+        </p:nvSpPr>
+        <p:spPr>
+          <a:xfrm>
+            <a:off x="6373368" y="2258568"/>
+            <a:ext cx="1664208" cy="347472"/>
+          </a:xfrm>
+          <a:prstGeom prst="rect">
+            <a:avLst/>
+          </a:prstGeom>
+          <a:noFill/>
+        </p:spPr>
+        <p:txBody>
+          <a:bodyPr wrap="square">
+            <a:spAutoFit/>
+          </a:bodyPr>
+          <a:lstStyle/>
+          <a:p>
+            <a:pPr algn="ctr"/>
+            <a:r>
+              <a:rPr sz="900" b="1" i="0">
+                <a:solidFill>
+                  <a:srgbClr val="FFFFFF"/>
+                </a:solidFill>
+              </a:rPr>
+              <a:t>/recommendations</a:t>
+            </a:r>
+          </a:p>
+        </p:txBody>
+      </p:sp>
+      <p:sp>
+        <p:nvSpPr>
+          <p:cNvPr id="26" name="Rectangle 25"/>
+          <p:cNvSpPr/>
+          <p:nvPr/>
+        </p:nvSpPr>
+        <p:spPr>
+          <a:xfrm>
+            <a:off x="8174736" y="2258568"/>
+            <a:ext cx="1664208" cy="347472"/>
+          </a:xfrm>
+          <a:prstGeom prst="rect">
+            <a:avLst/>
+          </a:prstGeom>
+          <a:solidFill>
+            <a:srgbClr val="243D72"/>
+          </a:solidFill>
+          <a:ln w="10160">
+            <a:solidFill>
+              <a:srgbClr val="F05A28"/>
+            </a:solidFill>
+          </a:ln>
+        </p:spPr>
+        <p:style>
+          <a:lnRef idx="1">
+            <a:schemeClr val="accent1"/>
+          </a:lnRef>
+          <a:fillRef idx="3">
+            <a:schemeClr val="accent1"/>
+          </a:fillRef>
+          <a:effectRef idx="2">
+            <a:schemeClr val="accent1"/>
+          </a:effectRef>
+          <a:fontRef idx="minor">
+            <a:schemeClr val="lt1"/>
+          </a:fontRef>
+        </p:style>
+        <p:txBody>
+          <a:bodyPr rtlCol="0" anchor="ctr"/>
+          <a:lstStyle/>
+          <a:p>
+            <a:pPr algn="ctr"/>
+          </a:p>
+        </p:txBody>
+      </p:sp>
+      <p:sp>
+        <p:nvSpPr>
+          <p:cNvPr id="27" name="TextBox 26"/>
+          <p:cNvSpPr txBox="1"/>
+          <p:nvPr/>
+        </p:nvSpPr>
+        <p:spPr>
+          <a:xfrm>
+            <a:off x="8174736" y="2258568"/>
+            <a:ext cx="1664208" cy="347472"/>
+          </a:xfrm>
+          <a:prstGeom prst="rect">
+            <a:avLst/>
+          </a:prstGeom>
+          <a:noFill/>
+        </p:spPr>
+        <p:txBody>
+          <a:bodyPr wrap="square">
+            <a:spAutoFit/>
+          </a:bodyPr>
+          <a:lstStyle/>
+          <a:p>
+            <a:pPr algn="ctr"/>
+            <a:r>
+              <a:rPr sz="900" b="1" i="0">
+                <a:solidFill>
+                  <a:srgbClr val="FFFFFF"/>
+                </a:solidFill>
+              </a:rPr>
+              <a:t>/agents/analyze</a:t>
+            </a:r>
+          </a:p>
+        </p:txBody>
+      </p:sp>
+      <p:sp>
+        <p:nvSpPr>
+          <p:cNvPr id="28" name="Rectangle 27"/>
+          <p:cNvSpPr/>
+          <p:nvPr/>
+        </p:nvSpPr>
+        <p:spPr>
+          <a:xfrm>
+            <a:off x="9976104" y="2258568"/>
+            <a:ext cx="1664208" cy="347472"/>
+          </a:xfrm>
+          <a:prstGeom prst="rect">
+            <a:avLst/>
+          </a:prstGeom>
+          <a:solidFill>
+            <a:srgbClr val="243D72"/>
+          </a:solidFill>
+          <a:ln w="10160">
+            <a:solidFill>
+              <a:srgbClr val="F05A28"/>
+            </a:solidFill>
+          </a:ln>
+        </p:spPr>
+        <p:style>
+          <a:lnRef idx="1">
+            <a:schemeClr val="accent1"/>
+          </a:lnRef>
+          <a:fillRef idx="3">
+            <a:schemeClr val="accent1"/>
+          </a:fillRef>
+          <a:effectRef idx="2">
+            <a:schemeClr val="accent1"/>
+          </a:effectRef>
+          <a:fontRef idx="minor">
+            <a:schemeClr val="lt1"/>
+          </a:fontRef>
+        </p:style>
+        <p:txBody>
+          <a:bodyPr rtlCol="0" anchor="ctr"/>
+          <a:lstStyle/>
+          <a:p>
+            <a:pPr algn="ctr"/>
+          </a:p>
+        </p:txBody>
+      </p:sp>
+      <p:sp>
+        <p:nvSpPr>
+          <p:cNvPr id="29" name="TextBox 28"/>
+          <p:cNvSpPr txBox="1"/>
+          <p:nvPr/>
+        </p:nvSpPr>
+        <p:spPr>
+          <a:xfrm>
+            <a:off x="9976104" y="2258568"/>
+            <a:ext cx="1664208" cy="347472"/>
+          </a:xfrm>
+          <a:prstGeom prst="rect">
+            <a:avLst/>
+          </a:prstGeom>
+          <a:noFill/>
+        </p:spPr>
+        <p:txBody>
+          <a:bodyPr wrap="square">
+            <a:spAutoFit/>
+          </a:bodyPr>
+          <a:lstStyle/>
+          <a:p>
+            <a:pPr algn="ctr"/>
+            <a:r>
+              <a:rPr sz="900" b="1" i="0">
+                <a:solidFill>
+                  <a:srgbClr val="FFFFFF"/>
+                </a:solidFill>
+              </a:rPr>
+              <a:t>/analytics</a:t>
+            </a:r>
+          </a:p>
+        </p:txBody>
+      </p:sp>
+      <p:sp>
+        <p:nvSpPr>
+          <p:cNvPr id="30" name="TextBox 29"/>
+          <p:cNvSpPr txBox="1"/>
+          <p:nvPr/>
+        </p:nvSpPr>
+        <p:spPr>
+          <a:xfrm>
+            <a:off x="5303520" y="2779776"/>
+            <a:ext cx="2743200" cy="219456"/>
+          </a:xfrm>
+          <a:prstGeom prst="rect">
+            <a:avLst/>
+          </a:prstGeom>
+          <a:noFill/>
+        </p:spPr>
+        <p:txBody>
+          <a:bodyPr wrap="square">
+            <a:spAutoFit/>
+          </a:bodyPr>
+          <a:lstStyle/>
+          <a:p>
+            <a:pPr algn="ctr"/>
+            <a:r>
+              <a:rPr sz="850" b="1" i="0">
+                <a:solidFill>
+                  <a:srgbClr val="C8D3E8"/>
+                </a:solidFill>
+              </a:rPr>
+              <a:t>▼  Routes to Services</a:t>
+            </a:r>
+          </a:p>
+        </p:txBody>
+      </p:sp>
+      <p:sp>
+        <p:nvSpPr>
+          <p:cNvPr id="31" name="Rectangle 30"/>
+          <p:cNvSpPr/>
+          <p:nvPr/>
+        </p:nvSpPr>
+        <p:spPr>
+          <a:xfrm>
+            <a:off x="365760" y="3017520"/>
+            <a:ext cx="2743200" cy="594360"/>
+          </a:xfrm>
+          <a:prstGeom prst="rect">
+            <a:avLst/>
+          </a:prstGeom>
+          <a:solidFill>
+            <a:srgbClr val="243D72"/>
+          </a:solidFill>
+          <a:ln>
+            <a:noFill/>
+          </a:ln>
+        </p:spPr>
+        <p:style>
+          <a:lnRef idx="1">
+            <a:schemeClr val="accent1"/>
+          </a:lnRef>
+          <a:fillRef idx="3">
+            <a:schemeClr val="accent1"/>
+          </a:fillRef>
+          <a:effectRef idx="2">
+            <a:schemeClr val="accent1"/>
+          </a:effectRef>
+          <a:fontRef idx="minor">
+            <a:schemeClr val="lt1"/>
+          </a:fontRef>
+        </p:style>
+        <p:txBody>
+          <a:bodyPr rtlCol="0" anchor="ctr"/>
+          <a:lstStyle/>
+          <a:p>
+            <a:pPr algn="ctr"/>
+          </a:p>
+        </p:txBody>
+      </p:sp>
+      <p:sp>
+        <p:nvSpPr>
+          <p:cNvPr id="32" name="TextBox 31"/>
+          <p:cNvSpPr txBox="1"/>
+          <p:nvPr/>
+        </p:nvSpPr>
+        <p:spPr>
+          <a:xfrm>
+            <a:off x="365760" y="3017520"/>
+            <a:ext cx="2743200" cy="594360"/>
+          </a:xfrm>
+          <a:prstGeom prst="rect">
+            <a:avLst/>
+          </a:prstGeom>
+          <a:noFill/>
+        </p:spPr>
+        <p:txBody>
+          <a:bodyPr wrap="square">
+            <a:spAutoFit/>
+          </a:bodyPr>
+          <a:lstStyle/>
+          <a:p>
+            <a:pPr algn="ctr"/>
+            <a:r>
+              <a:rPr sz="950" b="1" i="0">
+                <a:solidFill>
+                  <a:srgbClr val="FFFFFF"/>
+                </a:solidFill>
+              </a:rPr>
+              <a:t>RAG Service
+(search)</a:t>
+            </a:r>
+          </a:p>
+        </p:txBody>
+      </p:sp>
+      <p:sp>
+        <p:nvSpPr>
+          <p:cNvPr id="33" name="Rectangle 32"/>
+          <p:cNvSpPr/>
+          <p:nvPr/>
+        </p:nvSpPr>
+        <p:spPr>
+          <a:xfrm>
+            <a:off x="3246120" y="3017520"/>
+            <a:ext cx="2743200" cy="594360"/>
+          </a:xfrm>
+          <a:prstGeom prst="rect">
+            <a:avLst/>
+          </a:prstGeom>
+          <a:solidFill>
+            <a:srgbClr val="243D72"/>
+          </a:solidFill>
+          <a:ln>
+            <a:noFill/>
+          </a:ln>
+        </p:spPr>
+        <p:style>
+          <a:lnRef idx="1">
+            <a:schemeClr val="accent1"/>
+          </a:lnRef>
+          <a:fillRef idx="3">
+            <a:schemeClr val="accent1"/>
+          </a:fillRef>
+          <a:effectRef idx="2">
+            <a:schemeClr val="accent1"/>
+          </a:effectRef>
+          <a:fontRef idx="minor">
+            <a:schemeClr val="lt1"/>
+          </a:fontRef>
+        </p:style>
+        <p:txBody>
+          <a:bodyPr rtlCol="0" anchor="ctr"/>
+          <a:lstStyle/>
+          <a:p>
+            <a:pPr algn="ctr"/>
+          </a:p>
+        </p:txBody>
+      </p:sp>
+      <p:sp>
+        <p:nvSpPr>
+          <p:cNvPr id="34" name="TextBox 33"/>
+          <p:cNvSpPr txBox="1"/>
+          <p:nvPr/>
+        </p:nvSpPr>
+        <p:spPr>
+          <a:xfrm>
+            <a:off x="3246120" y="3017520"/>
+            <a:ext cx="2743200" cy="594360"/>
+          </a:xfrm>
+          <a:prstGeom prst="rect">
+            <a:avLst/>
+          </a:prstGeom>
+          <a:noFill/>
+        </p:spPr>
+        <p:txBody>
+          <a:bodyPr wrap="square">
+            <a:spAutoFit/>
+          </a:bodyPr>
+          <a:lstStyle/>
+          <a:p>
+            <a:pPr algn="ctr"/>
+            <a:r>
+              <a:rPr sz="950" b="1" i="0">
+                <a:solidFill>
+                  <a:srgbClr val="FFFFFF"/>
+                </a:solidFill>
+              </a:rPr>
+              <a:t>RAG Service
+(generate+recommend)</a:t>
+            </a:r>
+          </a:p>
+        </p:txBody>
+      </p:sp>
+      <p:sp>
+        <p:nvSpPr>
+          <p:cNvPr id="35" name="Rectangle 34"/>
+          <p:cNvSpPr/>
+          <p:nvPr/>
+        </p:nvSpPr>
+        <p:spPr>
+          <a:xfrm>
+            <a:off x="6126480" y="3017520"/>
+            <a:ext cx="2743200" cy="594360"/>
+          </a:xfrm>
+          <a:prstGeom prst="rect">
+            <a:avLst/>
+          </a:prstGeom>
+          <a:solidFill>
+            <a:srgbClr val="2E4A80"/>
+          </a:solidFill>
+          <a:ln>
+            <a:noFill/>
+          </a:ln>
+        </p:spPr>
+        <p:style>
+          <a:lnRef idx="1">
+            <a:schemeClr val="accent1"/>
+          </a:lnRef>
+          <a:fillRef idx="3">
+            <a:schemeClr val="accent1"/>
+          </a:fillRef>
+          <a:effectRef idx="2">
+            <a:schemeClr val="accent1"/>
+          </a:effectRef>
+          <a:fontRef idx="minor">
+            <a:schemeClr val="lt1"/>
+          </a:fontRef>
+        </p:style>
+        <p:txBody>
+          <a:bodyPr rtlCol="0" anchor="ctr"/>
+          <a:lstStyle/>
+          <a:p>
+            <a:pPr algn="ctr"/>
+          </a:p>
+        </p:txBody>
+      </p:sp>
+      <p:sp>
+        <p:nvSpPr>
+          <p:cNvPr id="36" name="TextBox 35"/>
+          <p:cNvSpPr txBox="1"/>
+          <p:nvPr/>
+        </p:nvSpPr>
+        <p:spPr>
+          <a:xfrm>
+            <a:off x="6126480" y="3017520"/>
+            <a:ext cx="2743200" cy="594360"/>
+          </a:xfrm>
+          <a:prstGeom prst="rect">
+            <a:avLst/>
+          </a:prstGeom>
+          <a:noFill/>
+        </p:spPr>
+        <p:txBody>
+          <a:bodyPr wrap="square">
+            <a:spAutoFit/>
+          </a:bodyPr>
+          <a:lstStyle/>
+          <a:p>
+            <a:pPr algn="ctr"/>
+            <a:r>
+              <a:rPr sz="950" b="1" i="0">
+                <a:solidFill>
+                  <a:srgbClr val="FFFFFF"/>
+                </a:solidFill>
+              </a:rPr>
+              <a:t>Orchestrator
+(multi-agent)</a:t>
+            </a:r>
+          </a:p>
+        </p:txBody>
+      </p:sp>
+      <p:sp>
+        <p:nvSpPr>
+          <p:cNvPr id="37" name="Rectangle 36"/>
+          <p:cNvSpPr/>
+          <p:nvPr/>
+        </p:nvSpPr>
+        <p:spPr>
+          <a:xfrm>
+            <a:off x="9006840" y="3017520"/>
+            <a:ext cx="2788920" cy="594360"/>
+          </a:xfrm>
+          <a:prstGeom prst="rect">
+            <a:avLst/>
+          </a:prstGeom>
+          <a:solidFill>
+            <a:srgbClr val="2E4A80"/>
+          </a:solidFill>
+          <a:ln>
+            <a:noFill/>
+          </a:ln>
+        </p:spPr>
+        <p:style>
+          <a:lnRef idx="1">
+            <a:schemeClr val="accent1"/>
+          </a:lnRef>
+          <a:fillRef idx="3">
+            <a:schemeClr val="accent1"/>
+          </a:fillRef>
+          <a:effectRef idx="2">
+            <a:schemeClr val="accent1"/>
+          </a:effectRef>
+          <a:fontRef idx="minor">
+            <a:schemeClr val="lt1"/>
+          </a:fontRef>
+        </p:style>
+        <p:txBody>
+          <a:bodyPr rtlCol="0" anchor="ctr"/>
+          <a:lstStyle/>
+          <a:p>
+            <a:pPr algn="ctr"/>
+          </a:p>
+        </p:txBody>
+      </p:sp>
+      <p:sp>
+        <p:nvSpPr>
+          <p:cNvPr id="38" name="TextBox 37"/>
+          <p:cNvSpPr txBox="1"/>
+          <p:nvPr/>
+        </p:nvSpPr>
+        <p:spPr>
+          <a:xfrm>
+            <a:off x="9006840" y="3017520"/>
+            <a:ext cx="2788920" cy="594360"/>
+          </a:xfrm>
+          <a:prstGeom prst="rect">
+            <a:avLst/>
+          </a:prstGeom>
+          <a:noFill/>
+        </p:spPr>
+        <p:txBody>
+          <a:bodyPr wrap="square">
+            <a:spAutoFit/>
+          </a:bodyPr>
+          <a:lstStyle/>
+          <a:p>
+            <a:pPr algn="ctr"/>
+            <a:r>
+              <a:rPr sz="950" b="1" i="0">
+                <a:solidFill>
+                  <a:srgbClr val="FFFFFF"/>
+                </a:solidFill>
+              </a:rPr>
+              <a:t>Analytics Service
+(dashboard/anomalies)</a:t>
+            </a:r>
+          </a:p>
+        </p:txBody>
+      </p:sp>
+      <p:sp>
+        <p:nvSpPr>
+          <p:cNvPr id="39" name="TextBox 38"/>
+          <p:cNvSpPr txBox="1"/>
+          <p:nvPr/>
+        </p:nvSpPr>
+        <p:spPr>
+          <a:xfrm>
+            <a:off x="5029200" y="3630168"/>
+            <a:ext cx="2743200" cy="219456"/>
+          </a:xfrm>
+          <a:prstGeom prst="rect">
+            <a:avLst/>
+          </a:prstGeom>
+          <a:noFill/>
+        </p:spPr>
+        <p:txBody>
+          <a:bodyPr wrap="square">
+            <a:spAutoFit/>
+          </a:bodyPr>
+          <a:lstStyle/>
+          <a:p>
+            <a:pPr algn="ctr"/>
+            <a:r>
+              <a:rPr sz="850" b="1" i="0">
+                <a:solidFill>
+                  <a:srgbClr val="C8D3E8"/>
+                </a:solidFill>
+              </a:rPr>
+              <a:t>▼  Shared Core Services</a:t>
+            </a:r>
+          </a:p>
+        </p:txBody>
+      </p:sp>
+      <p:sp>
+        <p:nvSpPr>
+          <p:cNvPr id="40" name="Rectangle 39"/>
+          <p:cNvSpPr/>
+          <p:nvPr/>
+        </p:nvSpPr>
+        <p:spPr>
+          <a:xfrm>
+            <a:off x="365760" y="3867912"/>
+            <a:ext cx="11430000" cy="566928"/>
+          </a:xfrm>
+          <a:prstGeom prst="rect">
+            <a:avLst/>
+          </a:prstGeom>
+          <a:solidFill>
+            <a:srgbClr val="182E60"/>
+          </a:solidFill>
+          <a:ln>
+            <a:noFill/>
+          </a:ln>
+        </p:spPr>
+        <p:style>
+          <a:lnRef idx="1">
+            <a:schemeClr val="accent1"/>
+          </a:lnRef>
+          <a:fillRef idx="3">
+            <a:schemeClr val="accent1"/>
+          </a:fillRef>
+          <a:effectRef idx="2">
+            <a:schemeClr val="accent1"/>
+          </a:effectRef>
+          <a:fontRef idx="minor">
+            <a:schemeClr val="lt1"/>
+          </a:fontRef>
+        </p:style>
+        <p:txBody>
+          <a:bodyPr rtlCol="0" anchor="ctr"/>
+          <a:lstStyle/>
+          <a:p>
+            <a:pPr algn="ctr"/>
+          </a:p>
+        </p:txBody>
+      </p:sp>
+      <p:sp>
+        <p:nvSpPr>
+          <p:cNvPr id="41" name="TextBox 40"/>
+          <p:cNvSpPr txBox="1"/>
+          <p:nvPr/>
+        </p:nvSpPr>
+        <p:spPr>
+          <a:xfrm>
+            <a:off x="502920" y="3886200"/>
+            <a:ext cx="2560320" cy="256032"/>
+          </a:xfrm>
+          <a:prstGeom prst="rect">
+            <a:avLst/>
+          </a:prstGeom>
+          <a:noFill/>
+        </p:spPr>
+        <p:txBody>
+          <a:bodyPr wrap="square">
+            <a:spAutoFit/>
+          </a:bodyPr>
+          <a:lstStyle/>
+          <a:p>
+            <a:pPr algn="l"/>
+            <a:r>
+              <a:rPr sz="850" b="1" i="0">
+                <a:solidFill>
+                  <a:srgbClr val="F05A28"/>
+                </a:solidFill>
+              </a:rPr>
+              <a:t>CORE SERVICES LAYER</a:t>
+            </a:r>
+          </a:p>
+        </p:txBody>
+      </p:sp>
+      <p:sp>
+        <p:nvSpPr>
+          <p:cNvPr id="42" name="Rectangle 41"/>
+          <p:cNvSpPr/>
+          <p:nvPr/>
+        </p:nvSpPr>
+        <p:spPr>
+          <a:xfrm>
+            <a:off x="457200" y="3904487"/>
+            <a:ext cx="2743200" cy="475488"/>
+          </a:xfrm>
+          <a:prstGeom prst="rect">
+            <a:avLst/>
+          </a:prstGeom>
+          <a:solidFill>
+            <a:srgbClr val="243D72"/>
+          </a:solidFill>
+          <a:ln w="8890">
+            <a:solidFill>
+              <a:srgbClr val="F05A28"/>
+            </a:solidFill>
+          </a:ln>
+        </p:spPr>
+        <p:style>
+          <a:lnRef idx="1">
+            <a:schemeClr val="accent1"/>
+          </a:lnRef>
+          <a:fillRef idx="3">
+            <a:schemeClr val="accent1"/>
+          </a:fillRef>
+          <a:effectRef idx="2">
+            <a:schemeClr val="accent1"/>
+          </a:effectRef>
+          <a:fontRef idx="minor">
+            <a:schemeClr val="lt1"/>
+          </a:fontRef>
+        </p:style>
+        <p:txBody>
+          <a:bodyPr rtlCol="0" anchor="ctr"/>
+          <a:lstStyle/>
+          <a:p>
+            <a:pPr algn="ctr"/>
+          </a:p>
+        </p:txBody>
+      </p:sp>
+      <p:sp>
+        <p:nvSpPr>
+          <p:cNvPr id="43" name="TextBox 42"/>
+          <p:cNvSpPr txBox="1"/>
+          <p:nvPr/>
+        </p:nvSpPr>
+        <p:spPr>
+          <a:xfrm>
+            <a:off x="457200" y="3904487"/>
+            <a:ext cx="2743200" cy="475488"/>
+          </a:xfrm>
+          <a:prstGeom prst="rect">
+            <a:avLst/>
+          </a:prstGeom>
+          <a:noFill/>
+        </p:spPr>
+        <p:txBody>
+          <a:bodyPr wrap="square">
+            <a:spAutoFit/>
+          </a:bodyPr>
+          <a:lstStyle/>
+          <a:p>
+            <a:pPr algn="ctr"/>
+            <a:r>
+              <a:rPr sz="900" b="0" i="0">
+                <a:solidFill>
+                  <a:srgbClr val="FFFFFF"/>
+                </a:solidFill>
+              </a:rPr>
+              <a:t>HybridSearch
+(BM25 + RRF)</a:t>
+            </a:r>
+          </a:p>
+        </p:txBody>
+      </p:sp>
+      <p:sp>
+        <p:nvSpPr>
+          <p:cNvPr id="44" name="Rectangle 43"/>
+          <p:cNvSpPr/>
+          <p:nvPr/>
+        </p:nvSpPr>
+        <p:spPr>
+          <a:xfrm>
+            <a:off x="3383280" y="3904487"/>
+            <a:ext cx="2743200" cy="475488"/>
+          </a:xfrm>
+          <a:prstGeom prst="rect">
+            <a:avLst/>
+          </a:prstGeom>
+          <a:solidFill>
+            <a:srgbClr val="243D72"/>
+          </a:solidFill>
+          <a:ln w="8890">
+            <a:solidFill>
+              <a:srgbClr val="F05A28"/>
+            </a:solidFill>
+          </a:ln>
+        </p:spPr>
+        <p:style>
+          <a:lnRef idx="1">
+            <a:schemeClr val="accent1"/>
+          </a:lnRef>
+          <a:fillRef idx="3">
+            <a:schemeClr val="accent1"/>
+          </a:fillRef>
+          <a:effectRef idx="2">
+            <a:schemeClr val="accent1"/>
+          </a:effectRef>
+          <a:fontRef idx="minor">
+            <a:schemeClr val="lt1"/>
+          </a:fontRef>
+        </p:style>
+        <p:txBody>
+          <a:bodyPr rtlCol="0" anchor="ctr"/>
+          <a:lstStyle/>
+          <a:p>
+            <a:pPr algn="ctr"/>
+          </a:p>
+        </p:txBody>
+      </p:sp>
+      <p:sp>
+        <p:nvSpPr>
+          <p:cNvPr id="45" name="TextBox 44"/>
+          <p:cNvSpPr txBox="1"/>
+          <p:nvPr/>
+        </p:nvSpPr>
+        <p:spPr>
+          <a:xfrm>
+            <a:off x="3383280" y="3904487"/>
+            <a:ext cx="2743200" cy="475488"/>
+          </a:xfrm>
+          <a:prstGeom prst="rect">
+            <a:avLst/>
+          </a:prstGeom>
+          <a:noFill/>
+        </p:spPr>
+        <p:txBody>
+          <a:bodyPr wrap="square">
+            <a:spAutoFit/>
+          </a:bodyPr>
+          <a:lstStyle/>
+          <a:p>
+            <a:pPr algn="ctr"/>
+            <a:r>
+              <a:rPr sz="900" b="0" i="0">
+                <a:solidFill>
+                  <a:srgbClr val="FFFFFF"/>
+                </a:solidFill>
+              </a:rPr>
+              <a:t>RiskScoring
+(4-dimension)</a:t>
+            </a:r>
+          </a:p>
+        </p:txBody>
+      </p:sp>
+      <p:sp>
+        <p:nvSpPr>
+          <p:cNvPr id="46" name="Rectangle 45"/>
+          <p:cNvSpPr/>
+          <p:nvPr/>
+        </p:nvSpPr>
+        <p:spPr>
+          <a:xfrm>
+            <a:off x="6309360" y="3904487"/>
+            <a:ext cx="2743200" cy="475488"/>
+          </a:xfrm>
+          <a:prstGeom prst="rect">
+            <a:avLst/>
+          </a:prstGeom>
+          <a:solidFill>
+            <a:srgbClr val="243D72"/>
+          </a:solidFill>
+          <a:ln w="8890">
+            <a:solidFill>
+              <a:srgbClr val="F05A28"/>
+            </a:solidFill>
+          </a:ln>
+        </p:spPr>
+        <p:style>
+          <a:lnRef idx="1">
+            <a:schemeClr val="accent1"/>
+          </a:lnRef>
+          <a:fillRef idx="3">
+            <a:schemeClr val="accent1"/>
+          </a:fillRef>
+          <a:effectRef idx="2">
+            <a:schemeClr val="accent1"/>
+          </a:effectRef>
+          <a:fontRef idx="minor">
+            <a:schemeClr val="lt1"/>
+          </a:fontRef>
+        </p:style>
+        <p:txBody>
+          <a:bodyPr rtlCol="0" anchor="ctr"/>
+          <a:lstStyle/>
+          <a:p>
+            <a:pPr algn="ctr"/>
+          </a:p>
+        </p:txBody>
+      </p:sp>
+      <p:sp>
+        <p:nvSpPr>
+          <p:cNvPr id="47" name="TextBox 46"/>
+          <p:cNvSpPr txBox="1"/>
+          <p:nvPr/>
+        </p:nvSpPr>
+        <p:spPr>
+          <a:xfrm>
+            <a:off x="6309360" y="3904487"/>
+            <a:ext cx="2743200" cy="475488"/>
+          </a:xfrm>
+          <a:prstGeom prst="rect">
+            <a:avLst/>
+          </a:prstGeom>
+          <a:noFill/>
+        </p:spPr>
+        <p:txBody>
+          <a:bodyPr wrap="square">
+            <a:spAutoFit/>
+          </a:bodyPr>
+          <a:lstStyle/>
+          <a:p>
+            <a:pPr algn="ctr"/>
+            <a:r>
+              <a:rPr sz="900" b="0" i="0">
+                <a:solidFill>
+                  <a:srgbClr val="FFFFFF"/>
+                </a:solidFill>
+              </a:rPr>
+              <a:t>Guardrails
+(validation)</a:t>
+            </a:r>
+          </a:p>
+        </p:txBody>
+      </p:sp>
+      <p:sp>
+        <p:nvSpPr>
+          <p:cNvPr id="48" name="Rectangle 47"/>
+          <p:cNvSpPr/>
+          <p:nvPr/>
+        </p:nvSpPr>
+        <p:spPr>
+          <a:xfrm>
+            <a:off x="9235440" y="3904487"/>
+            <a:ext cx="2743200" cy="475488"/>
+          </a:xfrm>
+          <a:prstGeom prst="rect">
+            <a:avLst/>
+          </a:prstGeom>
+          <a:solidFill>
+            <a:srgbClr val="243D72"/>
+          </a:solidFill>
+          <a:ln w="8890">
+            <a:solidFill>
+              <a:srgbClr val="F05A28"/>
+            </a:solidFill>
+          </a:ln>
+        </p:spPr>
+        <p:style>
+          <a:lnRef idx="1">
+            <a:schemeClr val="accent1"/>
+          </a:lnRef>
+          <a:fillRef idx="3">
+            <a:schemeClr val="accent1"/>
+          </a:fillRef>
+          <a:effectRef idx="2">
+            <a:schemeClr val="accent1"/>
+          </a:effectRef>
+          <a:fontRef idx="minor">
+            <a:schemeClr val="lt1"/>
+          </a:fontRef>
+        </p:style>
+        <p:txBody>
+          <a:bodyPr rtlCol="0" anchor="ctr"/>
+          <a:lstStyle/>
+          <a:p>
+            <a:pPr algn="ctr"/>
+          </a:p>
+        </p:txBody>
+      </p:sp>
+      <p:sp>
+        <p:nvSpPr>
+          <p:cNvPr id="49" name="TextBox 48"/>
+          <p:cNvSpPr txBox="1"/>
+          <p:nvPr/>
+        </p:nvSpPr>
+        <p:spPr>
+          <a:xfrm>
+            <a:off x="9235440" y="3904487"/>
+            <a:ext cx="2743200" cy="475488"/>
+          </a:xfrm>
+          <a:prstGeom prst="rect">
+            <a:avLst/>
+          </a:prstGeom>
+          <a:noFill/>
+        </p:spPr>
+        <p:txBody>
+          <a:bodyPr wrap="square">
+            <a:spAutoFit/>
+          </a:bodyPr>
+          <a:lstStyle/>
+          <a:p>
+            <a:pPr algn="ctr"/>
+            <a:r>
+              <a:rPr sz="900" b="0" i="0">
+                <a:solidFill>
+                  <a:srgbClr val="FFFFFF"/>
+                </a:solidFill>
+              </a:rPr>
+              <a:t>TokenOptimizer
+(tiktoken)</a:t>
+            </a:r>
+          </a:p>
+        </p:txBody>
+      </p:sp>
+      <p:sp>
+        <p:nvSpPr>
+          <p:cNvPr id="50" name="Rectangle 49"/>
+          <p:cNvSpPr/>
+          <p:nvPr/>
+        </p:nvSpPr>
+        <p:spPr>
+          <a:xfrm>
+            <a:off x="365760" y="4526280"/>
+            <a:ext cx="5303520" cy="987552"/>
+          </a:xfrm>
+          <a:prstGeom prst="rect">
+            <a:avLst/>
+          </a:prstGeom>
+          <a:solidFill>
+            <a:srgbClr val="122248"/>
+          </a:solidFill>
+          <a:ln w="12700">
+            <a:solidFill>
+              <a:srgbClr val="243D72"/>
+            </a:solidFill>
+          </a:ln>
+        </p:spPr>
+        <p:style>
+          <a:lnRef idx="1">
+            <a:schemeClr val="accent1"/>
+          </a:lnRef>
+          <a:fillRef idx="3">
+            <a:schemeClr val="accent1"/>
+          </a:fillRef>
+          <a:effectRef idx="2">
+            <a:schemeClr val="accent1"/>
+          </a:effectRef>
+          <a:fontRef idx="minor">
+            <a:schemeClr val="lt1"/>
+          </a:fontRef>
+        </p:style>
+        <p:txBody>
+          <a:bodyPr rtlCol="0" anchor="ctr"/>
+          <a:lstStyle/>
+          <a:p>
+            <a:pPr algn="ctr"/>
+          </a:p>
+        </p:txBody>
+      </p:sp>
+      <p:sp>
+        <p:nvSpPr>
+          <p:cNvPr id="51" name="TextBox 50"/>
+          <p:cNvSpPr txBox="1"/>
+          <p:nvPr/>
+        </p:nvSpPr>
+        <p:spPr>
+          <a:xfrm>
+            <a:off x="502920" y="4553712"/>
+            <a:ext cx="3200400" cy="274320"/>
+          </a:xfrm>
+          <a:prstGeom prst="rect">
+            <a:avLst/>
+          </a:prstGeom>
+          <a:noFill/>
+        </p:spPr>
+        <p:txBody>
+          <a:bodyPr wrap="square">
+            <a:spAutoFit/>
+          </a:bodyPr>
+          <a:lstStyle/>
+          <a:p>
+            <a:pPr algn="l"/>
+            <a:r>
+              <a:rPr sz="950" b="1" i="0">
+                <a:solidFill>
+                  <a:srgbClr val="F05A28"/>
+                </a:solidFill>
+              </a:rPr>
+              <a:t>NUMPY VECTOR STORE</a:t>
+            </a:r>
+          </a:p>
+        </p:txBody>
+      </p:sp>
+      <p:sp>
+        <p:nvSpPr>
+          <p:cNvPr id="52" name="TextBox 51"/>
+          <p:cNvSpPr txBox="1"/>
+          <p:nvPr/>
+        </p:nvSpPr>
+        <p:spPr>
+          <a:xfrm>
+            <a:off x="502920" y="4846320"/>
+            <a:ext cx="5029200" cy="594360"/>
+          </a:xfrm>
+          <a:prstGeom prst="rect">
+            <a:avLst/>
+          </a:prstGeom>
+          <a:noFill/>
+        </p:spPr>
+        <p:txBody>
+          <a:bodyPr wrap="square">
+            <a:spAutoFit/>
+          </a:bodyPr>
+          <a:lstStyle/>
+          <a:p>
+            <a:pPr algn="l"/>
+            <a:r>
+              <a:rPr sz="900" b="0" i="0">
+                <a:solidFill>
+                  <a:srgbClr val="C8D3E8"/>
+                </a:solidFill>
+              </a:rPr>
+              <a:t>embeddings.npy  ·  documents.json  ·  BM25 Index
+all-MiniLM-L6-v2 (384-dim) · store_meta.json (dimension guard)</a:t>
+            </a:r>
+          </a:p>
+        </p:txBody>
+      </p:sp>
+      <p:sp>
+        <p:nvSpPr>
+          <p:cNvPr id="53" name="Rectangle 52"/>
+          <p:cNvSpPr/>
+          <p:nvPr/>
+        </p:nvSpPr>
+        <p:spPr>
+          <a:xfrm>
+            <a:off x="6492240" y="4526280"/>
+            <a:ext cx="5303520" cy="987552"/>
+          </a:xfrm>
+          <a:prstGeom prst="rect">
+            <a:avLst/>
+          </a:prstGeom>
+          <a:solidFill>
+            <a:srgbClr val="F05A28"/>
+          </a:solidFill>
+          <a:ln w="15240">
+            <a:solidFill>
+              <a:srgbClr val="FFFFFF"/>
+            </a:solidFill>
+          </a:ln>
+        </p:spPr>
+        <p:style>
+          <a:lnRef idx="1">
+            <a:schemeClr val="accent1"/>
+          </a:lnRef>
+          <a:fillRef idx="3">
+            <a:schemeClr val="accent1"/>
+          </a:fillRef>
+          <a:effectRef idx="2">
+            <a:schemeClr val="accent1"/>
+          </a:effectRef>
+          <a:fontRef idx="minor">
+            <a:schemeClr val="lt1"/>
+          </a:fontRef>
+        </p:style>
+        <p:txBody>
+          <a:bodyPr rtlCol="0" anchor="ctr"/>
+          <a:lstStyle/>
+          <a:p>
+            <a:pPr algn="ctr"/>
+          </a:p>
+        </p:txBody>
+      </p:sp>
+      <p:sp>
+        <p:nvSpPr>
+          <p:cNvPr id="54" name="TextBox 53"/>
+          <p:cNvSpPr txBox="1"/>
+          <p:nvPr/>
+        </p:nvSpPr>
+        <p:spPr>
+          <a:xfrm>
+            <a:off x="6629400" y="4553712"/>
+            <a:ext cx="5029200" cy="274320"/>
+          </a:xfrm>
+          <a:prstGeom prst="rect">
+            <a:avLst/>
+          </a:prstGeom>
+          <a:noFill/>
+        </p:spPr>
+        <p:txBody>
+          <a:bodyPr wrap="square">
+            <a:spAutoFit/>
+          </a:bodyPr>
+          <a:lstStyle/>
+          <a:p>
+            <a:pPr algn="l"/>
+            <a:r>
+              <a:rPr sz="950" b="1" i="0">
+                <a:solidFill>
+                  <a:srgbClr val="FFFFFF"/>
+                </a:solidFill>
+              </a:rPr>
+              <a:t>OPENAI GPT-4o-mini  (via keygateway · SSL-off)</a:t>
+            </a:r>
+          </a:p>
+        </p:txBody>
+      </p:sp>
+      <p:sp>
+        <p:nvSpPr>
+          <p:cNvPr id="55" name="TextBox 54"/>
+          <p:cNvSpPr txBox="1"/>
+          <p:nvPr/>
+        </p:nvSpPr>
+        <p:spPr>
+          <a:xfrm>
+            <a:off x="6629400" y="4846320"/>
+            <a:ext cx="5029200" cy="594360"/>
+          </a:xfrm>
+          <a:prstGeom prst="rect">
+            <a:avLst/>
+          </a:prstGeom>
+          <a:noFill/>
+        </p:spPr>
+        <p:txBody>
+          <a:bodyPr wrap="square">
+            <a:spAutoFit/>
+          </a:bodyPr>
+          <a:lstStyle/>
+          <a:p>
+            <a:pPr algn="l"/>
+            <a:r>
+              <a:rPr sz="900" b="0" i="0">
+                <a:solidFill>
+                  <a:srgbClr val="FFE8D8"/>
+                </a:solidFill>
+              </a:rPr>
+              <a:t>• Recommendation generation (chat.completions, max_tokens=500)
+• Multi-agent tool use (function calling)  ·  LLM-as-judge evaluation</a:t>
+            </a:r>
+          </a:p>
+        </p:txBody>
+      </p:sp>
+      <p:sp>
+        <p:nvSpPr>
+          <p:cNvPr id="56" name="Rectangle 55"/>
+          <p:cNvSpPr/>
+          <p:nvPr/>
+        </p:nvSpPr>
+        <p:spPr>
+          <a:xfrm>
+            <a:off x="365760" y="5623560"/>
+            <a:ext cx="11430000" cy="594360"/>
+          </a:xfrm>
+          <a:prstGeom prst="rect">
+            <a:avLst/>
+          </a:prstGeom>
+          <a:solidFill>
+            <a:srgbClr val="0A1630"/>
+          </a:solidFill>
+          <a:ln>
+            <a:noFill/>
+          </a:ln>
+        </p:spPr>
+        <p:style>
+          <a:lnRef idx="1">
+            <a:schemeClr val="accent1"/>
+          </a:lnRef>
+          <a:fillRef idx="3">
+            <a:schemeClr val="accent1"/>
+          </a:fillRef>
+          <a:effectRef idx="2">
+            <a:schemeClr val="accent1"/>
+          </a:effectRef>
+          <a:fontRef idx="minor">
+            <a:schemeClr val="lt1"/>
+          </a:fontRef>
+        </p:style>
+        <p:txBody>
+          <a:bodyPr rtlCol="0" anchor="ctr"/>
+          <a:lstStyle/>
+          <a:p>
+            <a:pPr algn="ctr"/>
+          </a:p>
+        </p:txBody>
+      </p:sp>
+      <p:sp>
+        <p:nvSpPr>
+          <p:cNvPr id="57" name="TextBox 56"/>
+          <p:cNvSpPr txBox="1"/>
+          <p:nvPr/>
+        </p:nvSpPr>
+        <p:spPr>
+          <a:xfrm>
+            <a:off x="502920" y="5650992"/>
+            <a:ext cx="1645920" cy="256032"/>
+          </a:xfrm>
+          <a:prstGeom prst="rect">
+            <a:avLst/>
+          </a:prstGeom>
+          <a:noFill/>
+        </p:spPr>
+        <p:txBody>
+          <a:bodyPr wrap="square">
+            <a:spAutoFit/>
+          </a:bodyPr>
+          <a:lstStyle/>
+          <a:p>
+            <a:pPr algn="l"/>
+            <a:r>
+              <a:rPr sz="950" b="1" i="0">
+                <a:solidFill>
+                  <a:srgbClr val="F05A28"/>
+                </a:solidFill>
+              </a:rPr>
+              <a:t>DATA LAYER</a:t>
+            </a:r>
+          </a:p>
+        </p:txBody>
+      </p:sp>
+      <p:sp>
+        <p:nvSpPr>
+          <p:cNvPr id="58" name="TextBox 57"/>
+          <p:cNvSpPr txBox="1"/>
+          <p:nvPr/>
+        </p:nvSpPr>
+        <p:spPr>
+          <a:xfrm>
+            <a:off x="2286000" y="5650992"/>
+            <a:ext cx="9418320" cy="548640"/>
+          </a:xfrm>
+          <a:prstGeom prst="rect">
+            <a:avLst/>
+          </a:prstGeom>
+          <a:noFill/>
+        </p:spPr>
+        <p:txBody>
+          <a:bodyPr wrap="square">
+            <a:spAutoFit/>
+          </a:bodyPr>
+          <a:lstStyle/>
+          <a:p>
+            <a:pPr algn="l"/>
+            <a:r>
+              <a:rPr sz="950" b="0" i="0">
+                <a:solidFill>
+                  <a:srgbClr val="C8D3E8"/>
+                </a:solidFill>
+              </a:rPr>
+              <a:t>supply_chain_data.csv (600 incidents)  →  Preprocessing (coerce/enrich)  →  Chunking (tiktoken)  →  Embeddings  →  VectorStore upsert</a:t>
             </a:r>
           </a:p>
         </p:txBody>

</xml_diff>